<commit_message>
changes in inquiry module
</commit_message>
<xml_diff>
--- a/InfluenceAI_Project_Presentation.pptx
+++ b/InfluenceAI_Project_Presentation.pptx
@@ -16,6 +16,8 @@
     <p:sldId id="264" r:id="rId16"/>
     <p:sldId id="265" r:id="rId17"/>
     <p:sldId id="266" r:id="rId18"/>
+    <p:sldId id="274" r:id="rId26"/>
+    <p:sldId id="275" r:id="rId27"/>
     <p:sldId id="267" r:id="rId19"/>
     <p:sldId id="268" r:id="rId20"/>
     <p:sldId id="269" r:id="rId21"/>
@@ -6107,7 +6109,7 @@
     <p:bg>
       <p:bgPr>
         <a:solidFill>
-          <a:srgbClr val="F8FAFC"/>
+          <a:srgbClr val="0B0F19"/>
         </a:solidFill>
         <a:effectLst/>
       </p:bgPr>
@@ -6119,428 +6121,30 @@
         <p:nvPr/>
       </p:nvGrpSpPr>
       <p:grpSpPr/>
-      <p:sp>
-        <p:nvSpPr>
-          <p:cNvPr id="2" name="TextBox 1"/>
-          <p:cNvSpPr txBox="1"/>
-          <p:nvPr/>
-        </p:nvSpPr>
-        <p:spPr>
-          <a:xfrm>
-            <a:off x="731520" y="365760"/>
-            <a:ext cx="10698480" cy="365760"/>
+      <p:pic>
+        <p:nvPicPr>
+          <p:cNvPr id="2" name="Picture 1" descr="recommendation_engine_simple_flowchart.png"/>
+          <p:cNvPicPr>
+            <a:picLocks noChangeAspect="1"/>
+          </p:cNvPicPr>
+          <p:nvPr/>
+        </p:nvPicPr>
+        <p:blipFill>
+          <a:blip r:embed="rId3"/>
+          <a:stretch>
+            <a:fillRect/>
+          </a:stretch>
+        </p:blipFill>
+        <p:spPr>
+          <a:xfrm>
+            <a:off x="0" y="0"/>
+            <a:ext cx="12191695" cy="6858000"/>
           </a:xfrm>
           <a:prstGeom prst="rect">
             <a:avLst/>
           </a:prstGeom>
-          <a:noFill/>
-        </p:spPr>
-        <p:txBody>
-          <a:bodyPr wrap="square">
-            <a:spAutoFit/>
-          </a:bodyPr>
-          <a:lstStyle/>
-          <a:p>
-            <a:pPr>
-              <a:defRPr sz="1000" b="1">
-                <a:solidFill>
-                  <a:srgbClr val="4F46E5"/>
-                </a:solidFill>
-              </a:defRPr>
-            </a:pPr>
-            <a:r>
-              <a:t>INFLUENCEAI — AI-POWERED RECOMMENDATION SYSTEM</a:t>
-            </a:r>
-          </a:p>
-        </p:txBody>
-      </p:sp>
-      <p:sp>
-        <p:nvSpPr>
-          <p:cNvPr id="3" name="TextBox 2"/>
-          <p:cNvSpPr txBox="1"/>
-          <p:nvPr/>
-        </p:nvSpPr>
-        <p:spPr>
-          <a:xfrm>
-            <a:off x="731520" y="640080"/>
-            <a:ext cx="10698480" cy="731520"/>
-          </a:xfrm>
-          <a:prstGeom prst="rect">
-            <a:avLst/>
-          </a:prstGeom>
-          <a:noFill/>
-        </p:spPr>
-        <p:txBody>
-          <a:bodyPr wrap="square">
-            <a:spAutoFit/>
-          </a:bodyPr>
-          <a:lstStyle/>
-          <a:p>
-            <a:pPr>
-              <a:defRPr sz="2200" b="1">
-                <a:solidFill>
-                  <a:srgbClr val="0F172A"/>
-                </a:solidFill>
-              </a:defRPr>
-            </a:pPr>
-            <a:r>
-              <a:t>Phase 3 &amp; 4: Registered Channels &amp; Zero N+1 Email Mapping</a:t>
-            </a:r>
-          </a:p>
-        </p:txBody>
-      </p:sp>
-      <p:sp>
-        <p:nvSpPr>
-          <p:cNvPr id="4" name="Rounded Rectangle 3"/>
-          <p:cNvSpPr/>
-          <p:nvPr/>
-        </p:nvSpPr>
-        <p:spPr>
-          <a:xfrm>
-            <a:off x="731520" y="1463040"/>
-            <a:ext cx="5120640" cy="4846320"/>
-          </a:xfrm>
-          <a:prstGeom prst="roundRect">
-            <a:avLst/>
-          </a:prstGeom>
-          <a:solidFill>
-            <a:srgbClr val="FFFFFF"/>
-          </a:solidFill>
-          <a:ln w="12700">
-            <a:solidFill>
-              <a:srgbClr val="E2E8F0"/>
-            </a:solidFill>
-          </a:ln>
-        </p:spPr>
-        <p:style>
-          <a:lnRef idx="1">
-            <a:schemeClr val="accent1"/>
-          </a:lnRef>
-          <a:fillRef idx="3">
-            <a:schemeClr val="accent1"/>
-          </a:fillRef>
-          <a:effectRef idx="2">
-            <a:schemeClr val="accent1"/>
-          </a:effectRef>
-          <a:fontRef idx="minor">
-            <a:schemeClr val="lt1"/>
-          </a:fontRef>
-        </p:style>
-        <p:txBody>
-          <a:bodyPr rtlCol="0" anchor="ctr"/>
-          <a:lstStyle/>
-          <a:p>
-            <a:pPr algn="ctr"/>
-          </a:p>
-        </p:txBody>
-      </p:sp>
-      <p:sp>
-        <p:nvSpPr>
-          <p:cNvPr id="5" name="TextBox 4"/>
-          <p:cNvSpPr txBox="1"/>
-          <p:nvPr/>
-        </p:nvSpPr>
-        <p:spPr>
-          <a:xfrm>
-            <a:off x="914400" y="1645920"/>
-            <a:ext cx="4754880" cy="4480560"/>
-          </a:xfrm>
-          <a:prstGeom prst="rect">
-            <a:avLst/>
-          </a:prstGeom>
-          <a:noFill/>
-        </p:spPr>
-        <p:txBody>
-          <a:bodyPr wrap="square">
-            <a:spAutoFit/>
-          </a:bodyPr>
-          <a:lstStyle/>
-          <a:p>
-            <a:pPr>
-              <a:defRPr sz="1500" b="1">
-                <a:solidFill>
-                  <a:srgbClr val="4F46E5"/>
-                </a:solidFill>
-              </a:defRPr>
-            </a:pPr>
-            <a:r>
-              <a:t>Influencer Registration &amp; Ingestion Flow</a:t>
-            </a:r>
-          </a:p>
-          <a:p>
-            <a:pPr>
-              <a:defRPr sz="1100" b="1">
-                <a:solidFill>
-                  <a:srgbClr val="0F172A"/>
-                </a:solidFill>
-              </a:defRPr>
-            </a:pPr>
-            <a:r>
-              <a:t>• Creator Registration:</a:t>
-            </a:r>
-          </a:p>
-          <a:p>
-            <a:pPr>
-              <a:defRPr sz="1000">
-                <a:solidFill>
-                  <a:srgbClr val="64748B"/>
-                </a:solidFill>
-              </a:defRPr>
-            </a:pPr>
-            <a:r>
-              <a:t>   Creator submits YouTube channel ID, custom URL, or @handle + collaboration email.</a:t>
-            </a:r>
-          </a:p>
-          <a:p>
-            <a:pPr>
-              <a:defRPr sz="1100" b="1">
-                <a:solidFill>
-                  <a:srgbClr val="0F172A"/>
-                </a:solidFill>
-              </a:defRPr>
-            </a:pPr>
-            <a:r>
-              <a:t>• FastAPI Non-Blocking Task:</a:t>
-            </a:r>
-          </a:p>
-          <a:p>
-            <a:pPr>
-              <a:defRPr sz="1000">
-                <a:solidFill>
-                  <a:srgbClr val="64748B"/>
-                </a:solidFill>
-              </a:defRPr>
-            </a:pPr>
-            <a:r>
-              <a:t>   Triggered via FastAPI BackgroundTasks: validates channel with YouTube API, rejects duplicates.</a:t>
-            </a:r>
-          </a:p>
-          <a:p>
-            <a:pPr>
-              <a:defRPr sz="1100" b="1">
-                <a:solidFill>
-                  <a:srgbClr val="0F172A"/>
-                </a:solidFill>
-              </a:defRPr>
-            </a:pPr>
-            <a:r>
-              <a:t>• On-the-Fly SBERT Indexing:</a:t>
-            </a:r>
-          </a:p>
-          <a:p>
-            <a:pPr>
-              <a:defRPr sz="1000">
-                <a:solidFill>
-                  <a:srgbClr val="64748B"/>
-                </a:solidFill>
-              </a:defRPr>
-            </a:pPr>
-            <a:r>
-              <a:t>   Fetches latest 15 videos, computes 384-dim embedding vector, upserts to ml_data.channels, and invalidates in-memory candidate cache.</a:t>
-            </a:r>
-          </a:p>
-          <a:p>
-            <a:pPr>
-              <a:defRPr sz="1100" b="1">
-                <a:solidFill>
-                  <a:srgbClr val="0F172A"/>
-                </a:solidFill>
-              </a:defRPr>
-            </a:pPr>
-            <a:r>
-              <a:t>• Immediate Participation:</a:t>
-            </a:r>
-          </a:p>
-          <a:p>
-            <a:pPr>
-              <a:defRPr sz="1000">
-                <a:solidFill>
-                  <a:srgbClr val="64748B"/>
-                </a:solidFill>
-              </a:defRPr>
-            </a:pPr>
-            <a:r>
-              <a:t>   The registered creator immediately enters the active candidate pool and competes in recommendations without requiring a full model retrain.</a:t>
-            </a:r>
-          </a:p>
-        </p:txBody>
-      </p:sp>
-      <p:sp>
-        <p:nvSpPr>
-          <p:cNvPr id="6" name="Rounded Rectangle 5"/>
-          <p:cNvSpPr/>
-          <p:nvPr/>
-        </p:nvSpPr>
-        <p:spPr>
-          <a:xfrm>
-            <a:off x="6217920" y="1463040"/>
-            <a:ext cx="5212080" cy="4846320"/>
-          </a:xfrm>
-          <a:prstGeom prst="roundRect">
-            <a:avLst/>
-          </a:prstGeom>
-          <a:solidFill>
-            <a:srgbClr val="FFFFFF"/>
-          </a:solidFill>
-          <a:ln w="12700">
-            <a:solidFill>
-              <a:srgbClr val="E2E8F0"/>
-            </a:solidFill>
-          </a:ln>
-        </p:spPr>
-        <p:style>
-          <a:lnRef idx="1">
-            <a:schemeClr val="accent1"/>
-          </a:lnRef>
-          <a:fillRef idx="3">
-            <a:schemeClr val="accent1"/>
-          </a:fillRef>
-          <a:effectRef idx="2">
-            <a:schemeClr val="accent1"/>
-          </a:effectRef>
-          <a:fontRef idx="minor">
-            <a:schemeClr val="lt1"/>
-          </a:fontRef>
-        </p:style>
-        <p:txBody>
-          <a:bodyPr rtlCol="0" anchor="ctr"/>
-          <a:lstStyle/>
-          <a:p>
-            <a:pPr algn="ctr"/>
-          </a:p>
-        </p:txBody>
-      </p:sp>
-      <p:sp>
-        <p:nvSpPr>
-          <p:cNvPr id="7" name="TextBox 6"/>
-          <p:cNvSpPr txBox="1"/>
-          <p:nvPr/>
-        </p:nvSpPr>
-        <p:spPr>
-          <a:xfrm>
-            <a:off x="6400800" y="1645920"/>
-            <a:ext cx="4846320" cy="4480560"/>
-          </a:xfrm>
-          <a:prstGeom prst="rect">
-            <a:avLst/>
-          </a:prstGeom>
-          <a:noFill/>
-        </p:spPr>
-        <p:txBody>
-          <a:bodyPr wrap="square">
-            <a:spAutoFit/>
-          </a:bodyPr>
-          <a:lstStyle/>
-          <a:p>
-            <a:pPr>
-              <a:defRPr sz="1500" b="1">
-                <a:solidFill>
-                  <a:srgbClr val="7C3AED"/>
-                </a:solidFill>
-              </a:defRPr>
-            </a:pPr>
-            <a:r>
-              <a:t>Zero N+1 Batched Email Mapping</a:t>
-            </a:r>
-          </a:p>
-          <a:p>
-            <a:pPr>
-              <a:defRPr sz="1100" b="1">
-                <a:solidFill>
-                  <a:srgbClr val="0F172A"/>
-                </a:solidFill>
-              </a:defRPr>
-            </a:pPr>
-            <a:r>
-              <a:t>✔ The Challenge:</a:t>
-            </a:r>
-          </a:p>
-          <a:p>
-            <a:pPr>
-              <a:defRPr sz="1000">
-                <a:solidFill>
-                  <a:srgbClr val="64748B"/>
-                </a:solidFill>
-              </a:defRPr>
-            </a:pPr>
-            <a:r>
-              <a:t>   Avoid firing 10 individual SQL queries for 10 recommended channels (the notorious N+1 query antipattern).</a:t>
-            </a:r>
-          </a:p>
-          <a:p>
-            <a:pPr>
-              <a:defRPr sz="1100" b="1">
-                <a:solidFill>
-                  <a:srgbClr val="0F172A"/>
-                </a:solidFill>
-              </a:defRPr>
-            </a:pPr>
-            <a:r>
-              <a:t>✔ Single Batched Query:</a:t>
-            </a:r>
-          </a:p>
-          <a:p>
-            <a:pPr>
-              <a:defRPr sz="1000">
-                <a:solidFill>
-                  <a:srgbClr val="64748B"/>
-                </a:solidFill>
-              </a:defRPr>
-            </a:pPr>
-            <a:r>
-              <a:t>   SELECT youtube_channel_id, contact_email FROM public.registered_channels_public WHERE youtube_channel_id IN (:top_ids);</a:t>
-            </a:r>
-          </a:p>
-          <a:p>
-            <a:pPr>
-              <a:defRPr sz="1100" b="1">
-                <a:solidFill>
-                  <a:srgbClr val="0F172A"/>
-                </a:solidFill>
-              </a:defRPr>
-            </a:pPr>
-            <a:r>
-              <a:t>✔ Privacy Enforcement:</a:t>
-            </a:r>
-          </a:p>
-          <a:p>
-            <a:pPr>
-              <a:defRPr sz="1000">
-                <a:solidFill>
-                  <a:srgbClr val="64748B"/>
-                </a:solidFill>
-              </a:defRPr>
-            </a:pPr>
-            <a:r>
-              <a:t>   Only channels where show_email_publicly = true appear in the public view. Private emails remain secured.</a:t>
-            </a:r>
-          </a:p>
-          <a:p>
-            <a:pPr>
-              <a:defRPr sz="1100" b="1">
-                <a:solidFill>
-                  <a:srgbClr val="0F172A"/>
-                </a:solidFill>
-              </a:defRPr>
-            </a:pPr>
-            <a:r>
-              <a:t>✔ No Platform Bias:</a:t>
-            </a:r>
-          </a:p>
-          <a:p>
-            <a:pPr>
-              <a:defRPr sz="1000">
-                <a:solidFill>
-                  <a:srgbClr val="64748B"/>
-                </a:solidFill>
-              </a:defRPr>
-            </a:pPr>
-            <a:r>
-              <a:t>   Unregistered channels rank strictly on merit. Registered channels receive direct mailto/copy actions on their card without artificial badges.</a:t>
-            </a:r>
-          </a:p>
-        </p:txBody>
-      </p:sp>
+        </p:spPr>
+      </p:pic>
     </p:spTree>
   </p:cSld>
   <p:clrMapOvr>
@@ -6555,7 +6159,7 @@
     <p:bg>
       <p:bgPr>
         <a:solidFill>
-          <a:srgbClr val="F8FAFC"/>
+          <a:srgbClr val="0B0F19"/>
         </a:solidFill>
         <a:effectLst/>
       </p:bgPr>
@@ -6567,124 +6171,9 @@
         <p:nvPr/>
       </p:nvGrpSpPr>
       <p:grpSpPr/>
-      <p:sp>
-        <p:nvSpPr>
-          <p:cNvPr id="2" name="TextBox 1"/>
-          <p:cNvSpPr txBox="1"/>
-          <p:nvPr/>
-        </p:nvSpPr>
-        <p:spPr>
-          <a:xfrm>
-            <a:off x="731520" y="365760"/>
-            <a:ext cx="10698480" cy="365760"/>
-          </a:xfrm>
-          <a:prstGeom prst="rect">
-            <a:avLst/>
-          </a:prstGeom>
-          <a:noFill/>
-        </p:spPr>
-        <p:txBody>
-          <a:bodyPr wrap="square">
-            <a:spAutoFit/>
-          </a:bodyPr>
-          <a:lstStyle/>
-          <a:p>
-            <a:pPr>
-              <a:defRPr sz="1000" b="1">
-                <a:solidFill>
-                  <a:srgbClr val="4F46E5"/>
-                </a:solidFill>
-              </a:defRPr>
-            </a:pPr>
-            <a:r>
-              <a:t>INFLUENCEAI — AI-POWERED RECOMMENDATION SYSTEM</a:t>
-            </a:r>
-          </a:p>
-        </p:txBody>
-      </p:sp>
-      <p:sp>
-        <p:nvSpPr>
-          <p:cNvPr id="3" name="TextBox 2"/>
-          <p:cNvSpPr txBox="1"/>
-          <p:nvPr/>
-        </p:nvSpPr>
-        <p:spPr>
-          <a:xfrm>
-            <a:off x="731520" y="640080"/>
-            <a:ext cx="10698480" cy="731520"/>
-          </a:xfrm>
-          <a:prstGeom prst="rect">
-            <a:avLst/>
-          </a:prstGeom>
-          <a:noFill/>
-        </p:spPr>
-        <p:txBody>
-          <a:bodyPr wrap="square">
-            <a:spAutoFit/>
-          </a:bodyPr>
-          <a:lstStyle/>
-          <a:p>
-            <a:pPr>
-              <a:defRPr sz="2200" b="1">
-                <a:solidFill>
-                  <a:srgbClr val="0F172A"/>
-                </a:solidFill>
-              </a:defRPr>
-            </a:pPr>
-            <a:r>
-              <a:t>Brand User Experience: Complete Journey Flow</a:t>
-            </a:r>
-          </a:p>
-        </p:txBody>
-      </p:sp>
-      <p:sp>
-        <p:nvSpPr>
-          <p:cNvPr id="4" name="Rounded Rectangle 3"/>
-          <p:cNvSpPr/>
-          <p:nvPr/>
-        </p:nvSpPr>
-        <p:spPr>
-          <a:xfrm>
-            <a:off x="731520" y="1463040"/>
-            <a:ext cx="10698480" cy="2926080"/>
-          </a:xfrm>
-          <a:prstGeom prst="roundRect">
-            <a:avLst/>
-          </a:prstGeom>
-          <a:solidFill>
-            <a:srgbClr val="FFFFFF"/>
-          </a:solidFill>
-          <a:ln w="12700">
-            <a:solidFill>
-              <a:srgbClr val="E2E8F0"/>
-            </a:solidFill>
-          </a:ln>
-        </p:spPr>
-        <p:style>
-          <a:lnRef idx="1">
-            <a:schemeClr val="accent1"/>
-          </a:lnRef>
-          <a:fillRef idx="3">
-            <a:schemeClr val="accent1"/>
-          </a:fillRef>
-          <a:effectRef idx="2">
-            <a:schemeClr val="accent1"/>
-          </a:effectRef>
-          <a:fontRef idx="minor">
-            <a:schemeClr val="lt1"/>
-          </a:fontRef>
-        </p:style>
-        <p:txBody>
-          <a:bodyPr rtlCol="0" anchor="ctr"/>
-          <a:lstStyle/>
-          <a:p>
-            <a:pPr algn="ctr"/>
-          </a:p>
-        </p:txBody>
-      </p:sp>
       <p:pic>
         <p:nvPicPr>
-          <p:cNvPr id="5" name="Picture 4" descr="image5.jpg"/>
+          <p:cNvPr id="2" name="Picture 1" descr="recommendation_engine_3d_visual.jpg"/>
           <p:cNvPicPr>
             <a:picLocks noChangeAspect="1"/>
           </p:cNvPicPr>
@@ -6698,474 +6187,14 @@
         </p:blipFill>
         <p:spPr>
           <a:xfrm>
-            <a:off x="914400" y="1600200"/>
-            <a:ext cx="10332720" cy="2311946"/>
+            <a:off x="0" y="0"/>
+            <a:ext cx="12191695" cy="6858000"/>
           </a:xfrm>
           <a:prstGeom prst="rect">
             <a:avLst/>
           </a:prstGeom>
         </p:spPr>
       </p:pic>
-      <p:sp>
-        <p:nvSpPr>
-          <p:cNvPr id="6" name="Rounded Rectangle 5"/>
-          <p:cNvSpPr/>
-          <p:nvPr/>
-        </p:nvSpPr>
-        <p:spPr>
-          <a:xfrm>
-            <a:off x="731520" y="4572000"/>
-            <a:ext cx="2057400" cy="1737360"/>
-          </a:xfrm>
-          <a:prstGeom prst="roundRect">
-            <a:avLst/>
-          </a:prstGeom>
-          <a:solidFill>
-            <a:srgbClr val="FFFFFF"/>
-          </a:solidFill>
-          <a:ln w="12700">
-            <a:solidFill>
-              <a:srgbClr val="E2E8F0"/>
-            </a:solidFill>
-          </a:ln>
-        </p:spPr>
-        <p:style>
-          <a:lnRef idx="1">
-            <a:schemeClr val="accent1"/>
-          </a:lnRef>
-          <a:fillRef idx="3">
-            <a:schemeClr val="accent1"/>
-          </a:fillRef>
-          <a:effectRef idx="2">
-            <a:schemeClr val="accent1"/>
-          </a:effectRef>
-          <a:fontRef idx="minor">
-            <a:schemeClr val="lt1"/>
-          </a:fontRef>
-        </p:style>
-        <p:txBody>
-          <a:bodyPr rtlCol="0" anchor="ctr"/>
-          <a:lstStyle/>
-          <a:p>
-            <a:pPr algn="ctr"/>
-          </a:p>
-        </p:txBody>
-      </p:sp>
-      <p:sp>
-        <p:nvSpPr>
-          <p:cNvPr id="7" name="TextBox 6"/>
-          <p:cNvSpPr txBox="1"/>
-          <p:nvPr/>
-        </p:nvSpPr>
-        <p:spPr>
-          <a:xfrm>
-            <a:off x="822960" y="4709160"/>
-            <a:ext cx="1874519" cy="1463040"/>
-          </a:xfrm>
-          <a:prstGeom prst="rect">
-            <a:avLst/>
-          </a:prstGeom>
-          <a:noFill/>
-        </p:spPr>
-        <p:txBody>
-          <a:bodyPr wrap="square">
-            <a:spAutoFit/>
-          </a:bodyPr>
-          <a:lstStyle/>
-          <a:p>
-            <a:pPr>
-              <a:defRPr sz="1100" b="1">
-                <a:solidFill>
-                  <a:srgbClr val="4F46E5"/>
-                </a:solidFill>
-              </a:defRPr>
-            </a:pPr>
-            <a:r>
-              <a:t>Step 1: Register</a:t>
-            </a:r>
-          </a:p>
-          <a:p>
-            <a:pPr>
-              <a:defRPr sz="1000">
-                <a:solidFill>
-                  <a:srgbClr val="64748B"/>
-                </a:solidFill>
-              </a:defRPr>
-            </a:pPr>
-            <a:r>
-              <a:t>Brand creates account via Supabase Auth with company metadata.</a:t>
-            </a:r>
-          </a:p>
-        </p:txBody>
-      </p:sp>
-      <p:sp>
-        <p:nvSpPr>
-          <p:cNvPr id="8" name="Rounded Rectangle 7"/>
-          <p:cNvSpPr/>
-          <p:nvPr/>
-        </p:nvSpPr>
-        <p:spPr>
-          <a:xfrm>
-            <a:off x="2907791" y="4572000"/>
-            <a:ext cx="2057400" cy="1737360"/>
-          </a:xfrm>
-          <a:prstGeom prst="roundRect">
-            <a:avLst/>
-          </a:prstGeom>
-          <a:solidFill>
-            <a:srgbClr val="FFFFFF"/>
-          </a:solidFill>
-          <a:ln w="12700">
-            <a:solidFill>
-              <a:srgbClr val="E2E8F0"/>
-            </a:solidFill>
-          </a:ln>
-        </p:spPr>
-        <p:style>
-          <a:lnRef idx="1">
-            <a:schemeClr val="accent1"/>
-          </a:lnRef>
-          <a:fillRef idx="3">
-            <a:schemeClr val="accent1"/>
-          </a:fillRef>
-          <a:effectRef idx="2">
-            <a:schemeClr val="accent1"/>
-          </a:effectRef>
-          <a:fontRef idx="minor">
-            <a:schemeClr val="lt1"/>
-          </a:fontRef>
-        </p:style>
-        <p:txBody>
-          <a:bodyPr rtlCol="0" anchor="ctr"/>
-          <a:lstStyle/>
-          <a:p>
-            <a:pPr algn="ctr"/>
-          </a:p>
-        </p:txBody>
-      </p:sp>
-      <p:sp>
-        <p:nvSpPr>
-          <p:cNvPr id="9" name="TextBox 8"/>
-          <p:cNvSpPr txBox="1"/>
-          <p:nvPr/>
-        </p:nvSpPr>
-        <p:spPr>
-          <a:xfrm>
-            <a:off x="2999231" y="4709160"/>
-            <a:ext cx="1874519" cy="1463040"/>
-          </a:xfrm>
-          <a:prstGeom prst="rect">
-            <a:avLst/>
-          </a:prstGeom>
-          <a:noFill/>
-        </p:spPr>
-        <p:txBody>
-          <a:bodyPr wrap="square">
-            <a:spAutoFit/>
-          </a:bodyPr>
-          <a:lstStyle/>
-          <a:p>
-            <a:pPr>
-              <a:defRPr sz="1100" b="1">
-                <a:solidFill>
-                  <a:srgbClr val="7C3AED"/>
-                </a:solidFill>
-              </a:defRPr>
-            </a:pPr>
-            <a:r>
-              <a:t>Step 2: Authenticate</a:t>
-            </a:r>
-          </a:p>
-          <a:p>
-            <a:pPr>
-              <a:defRPr sz="1000">
-                <a:solidFill>
-                  <a:srgbClr val="64748B"/>
-                </a:solidFill>
-              </a:defRPr>
-            </a:pPr>
-            <a:r>
-              <a:t>Secure login with JWT persistence and ProtectedRoute guard.</a:t>
-            </a:r>
-          </a:p>
-        </p:txBody>
-      </p:sp>
-      <p:sp>
-        <p:nvSpPr>
-          <p:cNvPr id="10" name="Rounded Rectangle 9"/>
-          <p:cNvSpPr/>
-          <p:nvPr/>
-        </p:nvSpPr>
-        <p:spPr>
-          <a:xfrm>
-            <a:off x="5084064" y="4572000"/>
-            <a:ext cx="2057400" cy="1737360"/>
-          </a:xfrm>
-          <a:prstGeom prst="roundRect">
-            <a:avLst/>
-          </a:prstGeom>
-          <a:solidFill>
-            <a:srgbClr val="FFFFFF"/>
-          </a:solidFill>
-          <a:ln w="12700">
-            <a:solidFill>
-              <a:srgbClr val="E2E8F0"/>
-            </a:solidFill>
-          </a:ln>
-        </p:spPr>
-        <p:style>
-          <a:lnRef idx="1">
-            <a:schemeClr val="accent1"/>
-          </a:lnRef>
-          <a:fillRef idx="3">
-            <a:schemeClr val="accent1"/>
-          </a:fillRef>
-          <a:effectRef idx="2">
-            <a:schemeClr val="accent1"/>
-          </a:effectRef>
-          <a:fontRef idx="minor">
-            <a:schemeClr val="lt1"/>
-          </a:fontRef>
-        </p:style>
-        <p:txBody>
-          <a:bodyPr rtlCol="0" anchor="ctr"/>
-          <a:lstStyle/>
-          <a:p>
-            <a:pPr algn="ctr"/>
-          </a:p>
-        </p:txBody>
-      </p:sp>
-      <p:sp>
-        <p:nvSpPr>
-          <p:cNvPr id="11" name="TextBox 10"/>
-          <p:cNvSpPr txBox="1"/>
-          <p:nvPr/>
-        </p:nvSpPr>
-        <p:spPr>
-          <a:xfrm>
-            <a:off x="5175504" y="4709160"/>
-            <a:ext cx="1874519" cy="1463040"/>
-          </a:xfrm>
-          <a:prstGeom prst="rect">
-            <a:avLst/>
-          </a:prstGeom>
-          <a:noFill/>
-        </p:spPr>
-        <p:txBody>
-          <a:bodyPr wrap="square">
-            <a:spAutoFit/>
-          </a:bodyPr>
-          <a:lstStyle/>
-          <a:p>
-            <a:pPr>
-              <a:defRPr sz="1100" b="1">
-                <a:solidFill>
-                  <a:srgbClr val="0284C7"/>
-                </a:solidFill>
-              </a:defRPr>
-            </a:pPr>
-            <a:r>
-              <a:t>Step 3: Brand Profile</a:t>
-            </a:r>
-          </a:p>
-          <a:p>
-            <a:pPr>
-              <a:defRPr sz="1000">
-                <a:solidFill>
-                  <a:srgbClr val="64748B"/>
-                </a:solidFill>
-              </a:defRPr>
-            </a:pPr>
-            <a:r>
-              <a:t>Configures industry niche, website, state, and company context.</a:t>
-            </a:r>
-          </a:p>
-        </p:txBody>
-      </p:sp>
-      <p:sp>
-        <p:nvSpPr>
-          <p:cNvPr id="12" name="Rounded Rectangle 11"/>
-          <p:cNvSpPr/>
-          <p:nvPr/>
-        </p:nvSpPr>
-        <p:spPr>
-          <a:xfrm>
-            <a:off x="7260336" y="4572000"/>
-            <a:ext cx="2057400" cy="1737360"/>
-          </a:xfrm>
-          <a:prstGeom prst="roundRect">
-            <a:avLst/>
-          </a:prstGeom>
-          <a:solidFill>
-            <a:srgbClr val="FFFFFF"/>
-          </a:solidFill>
-          <a:ln w="12700">
-            <a:solidFill>
-              <a:srgbClr val="E2E8F0"/>
-            </a:solidFill>
-          </a:ln>
-        </p:spPr>
-        <p:style>
-          <a:lnRef idx="1">
-            <a:schemeClr val="accent1"/>
-          </a:lnRef>
-          <a:fillRef idx="3">
-            <a:schemeClr val="accent1"/>
-          </a:fillRef>
-          <a:effectRef idx="2">
-            <a:schemeClr val="accent1"/>
-          </a:effectRef>
-          <a:fontRef idx="minor">
-            <a:schemeClr val="lt1"/>
-          </a:fontRef>
-        </p:style>
-        <p:txBody>
-          <a:bodyPr rtlCol="0" anchor="ctr"/>
-          <a:lstStyle/>
-          <a:p>
-            <a:pPr algn="ctr"/>
-          </a:p>
-        </p:txBody>
-      </p:sp>
-      <p:sp>
-        <p:nvSpPr>
-          <p:cNvPr id="13" name="TextBox 12"/>
-          <p:cNvSpPr txBox="1"/>
-          <p:nvPr/>
-        </p:nvSpPr>
-        <p:spPr>
-          <a:xfrm>
-            <a:off x="7351776" y="4709160"/>
-            <a:ext cx="1874519" cy="1463040"/>
-          </a:xfrm>
-          <a:prstGeom prst="rect">
-            <a:avLst/>
-          </a:prstGeom>
-          <a:noFill/>
-        </p:spPr>
-        <p:txBody>
-          <a:bodyPr wrap="square">
-            <a:spAutoFit/>
-          </a:bodyPr>
-          <a:lstStyle/>
-          <a:p>
-            <a:pPr>
-              <a:defRPr sz="1100" b="1">
-                <a:solidFill>
-                  <a:srgbClr val="10B981"/>
-                </a:solidFill>
-              </a:defRPr>
-            </a:pPr>
-            <a:r>
-              <a:t>Step 4: Campaign Input</a:t>
-            </a:r>
-          </a:p>
-          <a:p>
-            <a:pPr>
-              <a:defRPr sz="1000">
-                <a:solidFill>
-                  <a:srgbClr val="64748B"/>
-                </a:solidFill>
-              </a:defRPr>
-            </a:pPr>
-            <a:r>
-              <a:t>Defines budget, category, country, goal, and brief text.</a:t>
-            </a:r>
-          </a:p>
-        </p:txBody>
-      </p:sp>
-      <p:sp>
-        <p:nvSpPr>
-          <p:cNvPr id="14" name="Rounded Rectangle 13"/>
-          <p:cNvSpPr/>
-          <p:nvPr/>
-        </p:nvSpPr>
-        <p:spPr>
-          <a:xfrm>
-            <a:off x="9436608" y="4572000"/>
-            <a:ext cx="2057400" cy="1737360"/>
-          </a:xfrm>
-          <a:prstGeom prst="roundRect">
-            <a:avLst/>
-          </a:prstGeom>
-          <a:solidFill>
-            <a:srgbClr val="FFFFFF"/>
-          </a:solidFill>
-          <a:ln w="12700">
-            <a:solidFill>
-              <a:srgbClr val="E2E8F0"/>
-            </a:solidFill>
-          </a:ln>
-        </p:spPr>
-        <p:style>
-          <a:lnRef idx="1">
-            <a:schemeClr val="accent1"/>
-          </a:lnRef>
-          <a:fillRef idx="3">
-            <a:schemeClr val="accent1"/>
-          </a:fillRef>
-          <a:effectRef idx="2">
-            <a:schemeClr val="accent1"/>
-          </a:effectRef>
-          <a:fontRef idx="minor">
-            <a:schemeClr val="lt1"/>
-          </a:fontRef>
-        </p:style>
-        <p:txBody>
-          <a:bodyPr rtlCol="0" anchor="ctr"/>
-          <a:lstStyle/>
-          <a:p>
-            <a:pPr algn="ctr"/>
-          </a:p>
-        </p:txBody>
-      </p:sp>
-      <p:sp>
-        <p:nvSpPr>
-          <p:cNvPr id="15" name="TextBox 14"/>
-          <p:cNvSpPr txBox="1"/>
-          <p:nvPr/>
-        </p:nvSpPr>
-        <p:spPr>
-          <a:xfrm>
-            <a:off x="9528048" y="4709160"/>
-            <a:ext cx="1874519" cy="1463040"/>
-          </a:xfrm>
-          <a:prstGeom prst="rect">
-            <a:avLst/>
-          </a:prstGeom>
-          <a:noFill/>
-        </p:spPr>
-        <p:txBody>
-          <a:bodyPr wrap="square">
-            <a:spAutoFit/>
-          </a:bodyPr>
-          <a:lstStyle/>
-          <a:p>
-            <a:pPr>
-              <a:defRPr sz="1100" b="1">
-                <a:solidFill>
-                  <a:srgbClr val="4F46E5"/>
-                </a:solidFill>
-              </a:defRPr>
-            </a:pPr>
-            <a:r>
-              <a:t>Step 5: Recommendations</a:t>
-            </a:r>
-          </a:p>
-          <a:p>
-            <a:pPr>
-              <a:defRPr sz="1000">
-                <a:solidFill>
-                  <a:srgbClr val="64748B"/>
-                </a:solidFill>
-              </a:defRPr>
-            </a:pPr>
-            <a:r>
-              <a:t>Receives ranked creator cards with direct email contact.</a:t>
-            </a:r>
-          </a:p>
-        </p:txBody>
-      </p:sp>
     </p:spTree>
   </p:cSld>
   <p:clrMapOvr>
@@ -7257,7 +6286,7 @@
               </a:defRPr>
             </a:pPr>
             <a:r>
-              <a:t>Platform Interface Showcase: React + Material-UI Frontend</a:t>
+              <a:t>Phase 3 &amp; 4: Registered Channels &amp; Zero N+1 Email Mapping</a:t>
             </a:r>
           </a:p>
         </p:txBody>
@@ -7271,7 +6300,7 @@
         <p:spPr>
           <a:xfrm>
             <a:off x="731520" y="1463040"/>
-            <a:ext cx="3429000" cy="4846320"/>
+            <a:ext cx="5120640" cy="4846320"/>
           </a:xfrm>
           <a:prstGeom prst="roundRect">
             <a:avLst/>
@@ -7307,40 +6336,16 @@
           </a:p>
         </p:txBody>
       </p:sp>
-      <p:pic>
-        <p:nvPicPr>
-          <p:cNvPr id="5" name="Picture 4" descr="image2.jpg"/>
-          <p:cNvPicPr>
-            <a:picLocks noChangeAspect="1"/>
-          </p:cNvPicPr>
-          <p:nvPr/>
-        </p:nvPicPr>
-        <p:blipFill>
-          <a:blip r:embed="rId2"/>
-          <a:stretch>
-            <a:fillRect/>
-          </a:stretch>
-        </p:blipFill>
+      <p:sp>
+        <p:nvSpPr>
+          <p:cNvPr id="5" name="TextBox 4"/>
+          <p:cNvSpPr txBox="1"/>
+          <p:nvPr/>
+        </p:nvSpPr>
         <p:spPr>
           <a:xfrm>
             <a:off x="914400" y="1645920"/>
-            <a:ext cx="3063240" cy="1719243"/>
-          </a:xfrm>
-          <a:prstGeom prst="rect">
-            <a:avLst/>
-          </a:prstGeom>
-        </p:spPr>
-      </p:pic>
-      <p:sp>
-        <p:nvSpPr>
-          <p:cNvPr id="6" name="TextBox 5"/>
-          <p:cNvSpPr txBox="1"/>
-          <p:nvPr/>
-        </p:nvSpPr>
-        <p:spPr>
-          <a:xfrm>
-            <a:off x="914400" y="4937760"/>
-            <a:ext cx="3063240" cy="1280160"/>
+            <a:ext cx="4754880" cy="4480560"/>
           </a:xfrm>
           <a:prstGeom prst="rect">
             <a:avLst/>
@@ -7354,14 +6359,26 @@
           <a:lstStyle/>
           <a:p>
             <a:pPr>
-              <a:defRPr sz="1200" b="1">
+              <a:defRPr sz="1500" b="1">
                 <a:solidFill>
                   <a:srgbClr val="4F46E5"/>
                 </a:solidFill>
               </a:defRPr>
             </a:pPr>
             <a:r>
-              <a:t>Landing &amp; Value Proposition</a:t>
+              <a:t>Influencer Registration &amp; Ingestion Flow</a:t>
+            </a:r>
+          </a:p>
+          <a:p>
+            <a:pPr>
+              <a:defRPr sz="1100" b="1">
+                <a:solidFill>
+                  <a:srgbClr val="0F172A"/>
+                </a:solidFill>
+              </a:defRPr>
+            </a:pPr>
+            <a:r>
+              <a:t>• Creator Registration:</a:t>
             </a:r>
           </a:p>
           <a:p>
@@ -7373,21 +6390,93 @@
               </a:defRPr>
             </a:pPr>
             <a:r>
-              <a:t>Clean hero section introducing semantic influencer intelligence.</a:t>
-            </a:r>
-          </a:p>
-        </p:txBody>
-      </p:sp>
-      <p:sp>
-        <p:nvSpPr>
-          <p:cNvPr id="7" name="Rounded Rectangle 6"/>
+              <a:t>   Creator submits YouTube channel ID, custom URL, or @handle + collaboration email.</a:t>
+            </a:r>
+          </a:p>
+          <a:p>
+            <a:pPr>
+              <a:defRPr sz="1100" b="1">
+                <a:solidFill>
+                  <a:srgbClr val="0F172A"/>
+                </a:solidFill>
+              </a:defRPr>
+            </a:pPr>
+            <a:r>
+              <a:t>• FastAPI Non-Blocking Task:</a:t>
+            </a:r>
+          </a:p>
+          <a:p>
+            <a:pPr>
+              <a:defRPr sz="1000">
+                <a:solidFill>
+                  <a:srgbClr val="64748B"/>
+                </a:solidFill>
+              </a:defRPr>
+            </a:pPr>
+            <a:r>
+              <a:t>   Triggered via FastAPI BackgroundTasks: validates channel with YouTube API, rejects duplicates.</a:t>
+            </a:r>
+          </a:p>
+          <a:p>
+            <a:pPr>
+              <a:defRPr sz="1100" b="1">
+                <a:solidFill>
+                  <a:srgbClr val="0F172A"/>
+                </a:solidFill>
+              </a:defRPr>
+            </a:pPr>
+            <a:r>
+              <a:t>• On-the-Fly SBERT Indexing:</a:t>
+            </a:r>
+          </a:p>
+          <a:p>
+            <a:pPr>
+              <a:defRPr sz="1000">
+                <a:solidFill>
+                  <a:srgbClr val="64748B"/>
+                </a:solidFill>
+              </a:defRPr>
+            </a:pPr>
+            <a:r>
+              <a:t>   Fetches latest 15 videos, computes 384-dim embedding vector, upserts to ml_data.channels, and invalidates in-memory candidate cache.</a:t>
+            </a:r>
+          </a:p>
+          <a:p>
+            <a:pPr>
+              <a:defRPr sz="1100" b="1">
+                <a:solidFill>
+                  <a:srgbClr val="0F172A"/>
+                </a:solidFill>
+              </a:defRPr>
+            </a:pPr>
+            <a:r>
+              <a:t>• Immediate Participation:</a:t>
+            </a:r>
+          </a:p>
+          <a:p>
+            <a:pPr>
+              <a:defRPr sz="1000">
+                <a:solidFill>
+                  <a:srgbClr val="64748B"/>
+                </a:solidFill>
+              </a:defRPr>
+            </a:pPr>
+            <a:r>
+              <a:t>   The registered creator immediately enters the active candidate pool and competes in recommendations without requiring a full model retrain.</a:t>
+            </a:r>
+          </a:p>
+        </p:txBody>
+      </p:sp>
+      <p:sp>
+        <p:nvSpPr>
+          <p:cNvPr id="6" name="Rounded Rectangle 5"/>
           <p:cNvSpPr/>
           <p:nvPr/>
         </p:nvSpPr>
         <p:spPr>
           <a:xfrm>
-            <a:off x="4343400" y="1463040"/>
-            <a:ext cx="3429000" cy="4846320"/>
+            <a:off x="6217920" y="1463040"/>
+            <a:ext cx="5212080" cy="4846320"/>
           </a:xfrm>
           <a:prstGeom prst="roundRect">
             <a:avLst/>
@@ -7423,40 +6512,16 @@
           </a:p>
         </p:txBody>
       </p:sp>
-      <p:pic>
-        <p:nvPicPr>
-          <p:cNvPr id="8" name="Picture 7" descr="image4.jpg"/>
-          <p:cNvPicPr>
-            <a:picLocks noChangeAspect="1"/>
-          </p:cNvPicPr>
-          <p:nvPr/>
-        </p:nvPicPr>
-        <p:blipFill>
-          <a:blip r:embed="rId3"/>
-          <a:stretch>
-            <a:fillRect/>
-          </a:stretch>
-        </p:blipFill>
-        <p:spPr>
-          <a:xfrm>
-            <a:off x="4526280" y="1645920"/>
-            <a:ext cx="3063240" cy="1721158"/>
-          </a:xfrm>
-          <a:prstGeom prst="rect">
-            <a:avLst/>
-          </a:prstGeom>
-        </p:spPr>
-      </p:pic>
-      <p:sp>
-        <p:nvSpPr>
-          <p:cNvPr id="9" name="TextBox 8"/>
+      <p:sp>
+        <p:nvSpPr>
+          <p:cNvPr id="7" name="TextBox 6"/>
           <p:cNvSpPr txBox="1"/>
           <p:nvPr/>
         </p:nvSpPr>
         <p:spPr>
           <a:xfrm>
-            <a:off x="4526280" y="4937760"/>
-            <a:ext cx="3063240" cy="1280160"/>
+            <a:off x="6400800" y="1645920"/>
+            <a:ext cx="4846320" cy="4480560"/>
           </a:xfrm>
           <a:prstGeom prst="rect">
             <a:avLst/>
@@ -7470,14 +6535,26 @@
           <a:lstStyle/>
           <a:p>
             <a:pPr>
-              <a:defRPr sz="1200" b="1">
-                <a:solidFill>
-                  <a:srgbClr val="4F46E5"/>
-                </a:solidFill>
-              </a:defRPr>
-            </a:pPr>
-            <a:r>
-              <a:t>Secure Supabase Authentication</a:t>
+              <a:defRPr sz="1500" b="1">
+                <a:solidFill>
+                  <a:srgbClr val="7C3AED"/>
+                </a:solidFill>
+              </a:defRPr>
+            </a:pPr>
+            <a:r>
+              <a:t>Zero N+1 Batched Email Mapping</a:t>
+            </a:r>
+          </a:p>
+          <a:p>
+            <a:pPr>
+              <a:defRPr sz="1100" b="1">
+                <a:solidFill>
+                  <a:srgbClr val="0F172A"/>
+                </a:solidFill>
+              </a:defRPr>
+            </a:pPr>
+            <a:r>
+              <a:t>✔ The Challenge:</a:t>
             </a:r>
           </a:p>
           <a:p>
@@ -7489,111 +6566,19 @@
               </a:defRPr>
             </a:pPr>
             <a:r>
-              <a:t>Dual-role authentication supporting Brand Partners and Creators.</a:t>
-            </a:r>
-          </a:p>
-        </p:txBody>
-      </p:sp>
-      <p:sp>
-        <p:nvSpPr>
-          <p:cNvPr id="10" name="Rounded Rectangle 9"/>
-          <p:cNvSpPr/>
-          <p:nvPr/>
-        </p:nvSpPr>
-        <p:spPr>
-          <a:xfrm>
-            <a:off x="7955280" y="1463040"/>
-            <a:ext cx="3429000" cy="4846320"/>
-          </a:xfrm>
-          <a:prstGeom prst="roundRect">
-            <a:avLst/>
-          </a:prstGeom>
-          <a:solidFill>
-            <a:srgbClr val="FFFFFF"/>
-          </a:solidFill>
-          <a:ln w="12700">
-            <a:solidFill>
-              <a:srgbClr val="E2E8F0"/>
-            </a:solidFill>
-          </a:ln>
-        </p:spPr>
-        <p:style>
-          <a:lnRef idx="1">
-            <a:schemeClr val="accent1"/>
-          </a:lnRef>
-          <a:fillRef idx="3">
-            <a:schemeClr val="accent1"/>
-          </a:fillRef>
-          <a:effectRef idx="2">
-            <a:schemeClr val="accent1"/>
-          </a:effectRef>
-          <a:fontRef idx="minor">
-            <a:schemeClr val="lt1"/>
-          </a:fontRef>
-        </p:style>
-        <p:txBody>
-          <a:bodyPr rtlCol="0" anchor="ctr"/>
-          <a:lstStyle/>
-          <a:p>
-            <a:pPr algn="ctr"/>
-          </a:p>
-        </p:txBody>
-      </p:sp>
-      <p:pic>
-        <p:nvPicPr>
-          <p:cNvPr id="11" name="Picture 10" descr="image3.jpg"/>
-          <p:cNvPicPr>
-            <a:picLocks noChangeAspect="1"/>
-          </p:cNvPicPr>
-          <p:nvPr/>
-        </p:nvPicPr>
-        <p:blipFill>
-          <a:blip r:embed="rId4"/>
-          <a:stretch>
-            <a:fillRect/>
-          </a:stretch>
-        </p:blipFill>
-        <p:spPr>
-          <a:xfrm>
-            <a:off x="8138160" y="1645920"/>
-            <a:ext cx="3063240" cy="1721158"/>
-          </a:xfrm>
-          <a:prstGeom prst="rect">
-            <a:avLst/>
-          </a:prstGeom>
-        </p:spPr>
-      </p:pic>
-      <p:sp>
-        <p:nvSpPr>
-          <p:cNvPr id="12" name="TextBox 11"/>
-          <p:cNvSpPr txBox="1"/>
-          <p:nvPr/>
-        </p:nvSpPr>
-        <p:spPr>
-          <a:xfrm>
-            <a:off x="8138160" y="4937760"/>
-            <a:ext cx="3063240" cy="1280160"/>
-          </a:xfrm>
-          <a:prstGeom prst="rect">
-            <a:avLst/>
-          </a:prstGeom>
-          <a:noFill/>
-        </p:spPr>
-        <p:txBody>
-          <a:bodyPr wrap="square">
-            <a:spAutoFit/>
-          </a:bodyPr>
-          <a:lstStyle/>
-          <a:p>
-            <a:pPr>
-              <a:defRPr sz="1200" b="1">
-                <a:solidFill>
-                  <a:srgbClr val="4F46E5"/>
-                </a:solidFill>
-              </a:defRPr>
-            </a:pPr>
-            <a:r>
-              <a:t>Campaign Creation Dashboard</a:t>
+              <a:t>   Avoid firing 10 individual SQL queries for 10 recommended channels (the notorious N+1 query antipattern).</a:t>
+            </a:r>
+          </a:p>
+          <a:p>
+            <a:pPr>
+              <a:defRPr sz="1100" b="1">
+                <a:solidFill>
+                  <a:srgbClr val="0F172A"/>
+                </a:solidFill>
+              </a:defRPr>
+            </a:pPr>
+            <a:r>
+              <a:t>✔ Single Batched Query:</a:t>
             </a:r>
           </a:p>
           <a:p>
@@ -7605,7 +6590,55 @@
               </a:defRPr>
             </a:pPr>
             <a:r>
-              <a:t>Intuitive input matrix for category, budget, location, and brief.</a:t>
+              <a:t>   SELECT youtube_channel_id, contact_email FROM public.registered_channels_public WHERE youtube_channel_id IN (:top_ids);</a:t>
+            </a:r>
+          </a:p>
+          <a:p>
+            <a:pPr>
+              <a:defRPr sz="1100" b="1">
+                <a:solidFill>
+                  <a:srgbClr val="0F172A"/>
+                </a:solidFill>
+              </a:defRPr>
+            </a:pPr>
+            <a:r>
+              <a:t>✔ Privacy Enforcement:</a:t>
+            </a:r>
+          </a:p>
+          <a:p>
+            <a:pPr>
+              <a:defRPr sz="1000">
+                <a:solidFill>
+                  <a:srgbClr val="64748B"/>
+                </a:solidFill>
+              </a:defRPr>
+            </a:pPr>
+            <a:r>
+              <a:t>   Only channels where show_email_publicly = true appear in the public view. Private emails remain secured.</a:t>
+            </a:r>
+          </a:p>
+          <a:p>
+            <a:pPr>
+              <a:defRPr sz="1100" b="1">
+                <a:solidFill>
+                  <a:srgbClr val="0F172A"/>
+                </a:solidFill>
+              </a:defRPr>
+            </a:pPr>
+            <a:r>
+              <a:t>✔ No Platform Bias:</a:t>
+            </a:r>
+          </a:p>
+          <a:p>
+            <a:pPr>
+              <a:defRPr sz="1000">
+                <a:solidFill>
+                  <a:srgbClr val="64748B"/>
+                </a:solidFill>
+              </a:defRPr>
+            </a:pPr>
+            <a:r>
+              <a:t>   Unregistered channels rank strictly on merit. Registered channels receive direct mailto/copy actions on their card without artificial badges.</a:t>
             </a:r>
           </a:p>
         </p:txBody>
@@ -7701,7 +6734,7 @@
               </a:defRPr>
             </a:pPr>
             <a:r>
-              <a:t>Explainable AI: Why Was This Creator Recommended?</a:t>
+              <a:t>Brand User Experience: Complete Journey Flow</a:t>
             </a:r>
           </a:p>
         </p:txBody>
@@ -7715,7 +6748,7 @@
         <p:spPr>
           <a:xfrm>
             <a:off x="731520" y="1463040"/>
-            <a:ext cx="5257800" cy="2240280"/>
+            <a:ext cx="10698480" cy="2926080"/>
           </a:xfrm>
           <a:prstGeom prst="roundRect">
             <a:avLst/>
@@ -7751,77 +6784,30 @@
           </a:p>
         </p:txBody>
       </p:sp>
-      <p:sp>
-        <p:nvSpPr>
-          <p:cNvPr id="5" name="TextBox 4"/>
-          <p:cNvSpPr txBox="1"/>
-          <p:nvPr/>
-        </p:nvSpPr>
-        <p:spPr>
-          <a:xfrm>
-            <a:off x="914400" y="1645920"/>
-            <a:ext cx="4892040" cy="1874519"/>
+      <p:pic>
+        <p:nvPicPr>
+          <p:cNvPr id="5" name="Picture 4" descr="image5.jpg"/>
+          <p:cNvPicPr>
+            <a:picLocks noChangeAspect="1"/>
+          </p:cNvPicPr>
+          <p:nvPr/>
+        </p:nvPicPr>
+        <p:blipFill>
+          <a:blip r:embed="rId2"/>
+          <a:stretch>
+            <a:fillRect/>
+          </a:stretch>
+        </p:blipFill>
+        <p:spPr>
+          <a:xfrm>
+            <a:off x="914400" y="1600200"/>
+            <a:ext cx="10332720" cy="2311946"/>
           </a:xfrm>
           <a:prstGeom prst="rect">
             <a:avLst/>
           </a:prstGeom>
-          <a:noFill/>
-        </p:spPr>
-        <p:txBody>
-          <a:bodyPr wrap="square">
-            <a:spAutoFit/>
-          </a:bodyPr>
-          <a:lstStyle/>
-          <a:p>
-            <a:pPr>
-              <a:defRPr sz="1300" b="1">
-                <a:solidFill>
-                  <a:srgbClr val="4F46E5"/>
-                </a:solidFill>
-              </a:defRPr>
-            </a:pPr>
-            <a:r>
-              <a:t>Semantic Match Breakdown</a:t>
-            </a:r>
-          </a:p>
-          <a:p>
-            <a:pPr>
-              <a:defRPr sz="1100">
-                <a:solidFill>
-                  <a:srgbClr val="0F172A"/>
-                </a:solidFill>
-              </a:defRPr>
-            </a:pPr>
-            <a:r>
-              <a:t>• Displays exact semantic similarity percentage (e.g. 84% Match).</a:t>
-            </a:r>
-          </a:p>
-          <a:p>
-            <a:pPr>
-              <a:defRPr sz="1100">
-                <a:solidFill>
-                  <a:srgbClr val="0F172A"/>
-                </a:solidFill>
-              </a:defRPr>
-            </a:pPr>
-            <a:r>
-              <a:t>• Explains the contextual connection between creator's recent video themes and campaign keywords.</a:t>
-            </a:r>
-          </a:p>
-          <a:p>
-            <a:pPr>
-              <a:defRPr sz="1100">
-                <a:solidFill>
-                  <a:srgbClr val="0F172A"/>
-                </a:solidFill>
-              </a:defRPr>
-            </a:pPr>
-            <a:r>
-              <a:t>• Eliminates 'black-box' recommendations so marketing teams understand the match rationale.</a:t>
-            </a:r>
-          </a:p>
-        </p:txBody>
-      </p:sp>
+        </p:spPr>
+      </p:pic>
       <p:sp>
         <p:nvSpPr>
           <p:cNvPr id="6" name="Rounded Rectangle 5"/>
@@ -7830,8 +6816,8 @@
         </p:nvSpPr>
         <p:spPr>
           <a:xfrm>
-            <a:off x="6172200" y="1463040"/>
-            <a:ext cx="5257800" cy="2240280"/>
+            <a:off x="731520" y="4572000"/>
+            <a:ext cx="2057400" cy="1737360"/>
           </a:xfrm>
           <a:prstGeom prst="roundRect">
             <a:avLst/>
@@ -7875,8 +6861,8 @@
         </p:nvSpPr>
         <p:spPr>
           <a:xfrm>
-            <a:off x="6355080" y="1645920"/>
-            <a:ext cx="4892040" cy="1874519"/>
+            <a:off x="822960" y="4709160"/>
+            <a:ext cx="1874519" cy="1463040"/>
           </a:xfrm>
           <a:prstGeom prst="rect">
             <a:avLst/>
@@ -7890,50 +6876,26 @@
           <a:lstStyle/>
           <a:p>
             <a:pPr>
-              <a:defRPr sz="1300" b="1">
-                <a:solidFill>
-                  <a:srgbClr val="7C3AED"/>
-                </a:solidFill>
-              </a:defRPr>
-            </a:pPr>
-            <a:r>
-              <a:t>Engagement Quality Index</a:t>
-            </a:r>
-          </a:p>
-          <a:p>
-            <a:pPr>
-              <a:defRPr sz="1100">
-                <a:solidFill>
-                  <a:srgbClr val="0F172A"/>
-                </a:solidFill>
-              </a:defRPr>
-            </a:pPr>
-            <a:r>
-              <a:t>• Transparently reports audience engagement rate (e.g. 4.82% ER).</a:t>
-            </a:r>
-          </a:p>
-          <a:p>
-            <a:pPr>
-              <a:defRPr sz="1100">
-                <a:solidFill>
-                  <a:srgbClr val="0F172A"/>
-                </a:solidFill>
-              </a:defRPr>
-            </a:pPr>
-            <a:r>
-              <a:t>• Shows normalized percentile ranking within their specific category.</a:t>
-            </a:r>
-          </a:p>
-          <a:p>
-            <a:pPr>
-              <a:defRPr sz="1100">
-                <a:solidFill>
-                  <a:srgbClr val="0F172A"/>
-                </a:solidFill>
-              </a:defRPr>
-            </a:pPr>
-            <a:r>
-              <a:t>• Verifies active recent viewership rather than dormant historical follower counts.</a:t>
+              <a:defRPr sz="1100" b="1">
+                <a:solidFill>
+                  <a:srgbClr val="4F46E5"/>
+                </a:solidFill>
+              </a:defRPr>
+            </a:pPr>
+            <a:r>
+              <a:t>Step 1: Register</a:t>
+            </a:r>
+          </a:p>
+          <a:p>
+            <a:pPr>
+              <a:defRPr sz="1000">
+                <a:solidFill>
+                  <a:srgbClr val="64748B"/>
+                </a:solidFill>
+              </a:defRPr>
+            </a:pPr>
+            <a:r>
+              <a:t>Brand creates account via Supabase Auth with company metadata.</a:t>
             </a:r>
           </a:p>
         </p:txBody>
@@ -7946,8 +6908,8 @@
         </p:nvSpPr>
         <p:spPr>
           <a:xfrm>
-            <a:off x="731520" y="3931920"/>
-            <a:ext cx="5257800" cy="2240280"/>
+            <a:off x="2907791" y="4572000"/>
+            <a:ext cx="2057400" cy="1737360"/>
           </a:xfrm>
           <a:prstGeom prst="roundRect">
             <a:avLst/>
@@ -7991,8 +6953,8 @@
         </p:nvSpPr>
         <p:spPr>
           <a:xfrm>
-            <a:off x="914400" y="4114800"/>
-            <a:ext cx="4892040" cy="1874519"/>
+            <a:off x="2999231" y="4709160"/>
+            <a:ext cx="1874519" cy="1463040"/>
           </a:xfrm>
           <a:prstGeom prst="rect">
             <a:avLst/>
@@ -8006,50 +6968,26 @@
           <a:lstStyle/>
           <a:p>
             <a:pPr>
-              <a:defRPr sz="1300" b="1">
-                <a:solidFill>
-                  <a:srgbClr val="0284C7"/>
-                </a:solidFill>
-              </a:defRPr>
-            </a:pPr>
-            <a:r>
-              <a:t>Budget &amp; Creator Collab Fit</a:t>
-            </a:r>
-          </a:p>
-          <a:p>
-            <a:pPr>
-              <a:defRPr sz="1100">
-                <a:solidFill>
-                  <a:srgbClr val="0F172A"/>
-                </a:solidFill>
-              </a:defRPr>
-            </a:pPr>
-            <a:r>
-              <a:t>• Estimated collaboration cost calculated via standard Indian market formulas.</a:t>
-            </a:r>
-          </a:p>
-          <a:p>
-            <a:pPr>
-              <a:defRPr sz="1100">
-                <a:solidFill>
-                  <a:srgbClr val="0F172A"/>
-                </a:solidFill>
-              </a:defRPr>
-            </a:pPr>
-            <a:r>
-              <a:t>• Tier classification (Nano, Micro, Mid, Macro) explicitly identified.</a:t>
-            </a:r>
-          </a:p>
-          <a:p>
-            <a:pPr>
-              <a:defRPr sz="1100">
-                <a:solidFill>
-                  <a:srgbClr val="0F172A"/>
-                </a:solidFill>
-              </a:defRPr>
-            </a:pPr>
-            <a:r>
-              <a:t>• Confirms whether creator fee fits comfortably within campaign budget.</a:t>
+              <a:defRPr sz="1100" b="1">
+                <a:solidFill>
+                  <a:srgbClr val="7C3AED"/>
+                </a:solidFill>
+              </a:defRPr>
+            </a:pPr>
+            <a:r>
+              <a:t>Step 2: Authenticate</a:t>
+            </a:r>
+          </a:p>
+          <a:p>
+            <a:pPr>
+              <a:defRPr sz="1000">
+                <a:solidFill>
+                  <a:srgbClr val="64748B"/>
+                </a:solidFill>
+              </a:defRPr>
+            </a:pPr>
+            <a:r>
+              <a:t>Secure login with JWT persistence and ProtectedRoute guard.</a:t>
             </a:r>
           </a:p>
         </p:txBody>
@@ -8062,8 +7000,8 @@
         </p:nvSpPr>
         <p:spPr>
           <a:xfrm>
-            <a:off x="6172200" y="3931920"/>
-            <a:ext cx="5257800" cy="2240280"/>
+            <a:off x="5084064" y="4572000"/>
+            <a:ext cx="2057400" cy="1737360"/>
           </a:xfrm>
           <a:prstGeom prst="roundRect">
             <a:avLst/>
@@ -8107,8 +7045,8 @@
         </p:nvSpPr>
         <p:spPr>
           <a:xfrm>
-            <a:off x="6355080" y="4114800"/>
-            <a:ext cx="4892040" cy="1874519"/>
+            <a:off x="5175504" y="4709160"/>
+            <a:ext cx="1874519" cy="1463040"/>
           </a:xfrm>
           <a:prstGeom prst="rect">
             <a:avLst/>
@@ -8122,50 +7060,210 @@
           <a:lstStyle/>
           <a:p>
             <a:pPr>
-              <a:defRPr sz="1300" b="1">
+              <a:defRPr sz="1100" b="1">
+                <a:solidFill>
+                  <a:srgbClr val="0284C7"/>
+                </a:solidFill>
+              </a:defRPr>
+            </a:pPr>
+            <a:r>
+              <a:t>Step 3: Brand Profile</a:t>
+            </a:r>
+          </a:p>
+          <a:p>
+            <a:pPr>
+              <a:defRPr sz="1000">
+                <a:solidFill>
+                  <a:srgbClr val="64748B"/>
+                </a:solidFill>
+              </a:defRPr>
+            </a:pPr>
+            <a:r>
+              <a:t>Configures industry niche, website, state, and company context.</a:t>
+            </a:r>
+          </a:p>
+        </p:txBody>
+      </p:sp>
+      <p:sp>
+        <p:nvSpPr>
+          <p:cNvPr id="12" name="Rounded Rectangle 11"/>
+          <p:cNvSpPr/>
+          <p:nvPr/>
+        </p:nvSpPr>
+        <p:spPr>
+          <a:xfrm>
+            <a:off x="7260336" y="4572000"/>
+            <a:ext cx="2057400" cy="1737360"/>
+          </a:xfrm>
+          <a:prstGeom prst="roundRect">
+            <a:avLst/>
+          </a:prstGeom>
+          <a:solidFill>
+            <a:srgbClr val="FFFFFF"/>
+          </a:solidFill>
+          <a:ln w="12700">
+            <a:solidFill>
+              <a:srgbClr val="E2E8F0"/>
+            </a:solidFill>
+          </a:ln>
+        </p:spPr>
+        <p:style>
+          <a:lnRef idx="1">
+            <a:schemeClr val="accent1"/>
+          </a:lnRef>
+          <a:fillRef idx="3">
+            <a:schemeClr val="accent1"/>
+          </a:fillRef>
+          <a:effectRef idx="2">
+            <a:schemeClr val="accent1"/>
+          </a:effectRef>
+          <a:fontRef idx="minor">
+            <a:schemeClr val="lt1"/>
+          </a:fontRef>
+        </p:style>
+        <p:txBody>
+          <a:bodyPr rtlCol="0" anchor="ctr"/>
+          <a:lstStyle/>
+          <a:p>
+            <a:pPr algn="ctr"/>
+          </a:p>
+        </p:txBody>
+      </p:sp>
+      <p:sp>
+        <p:nvSpPr>
+          <p:cNvPr id="13" name="TextBox 12"/>
+          <p:cNvSpPr txBox="1"/>
+          <p:nvPr/>
+        </p:nvSpPr>
+        <p:spPr>
+          <a:xfrm>
+            <a:off x="7351776" y="4709160"/>
+            <a:ext cx="1874519" cy="1463040"/>
+          </a:xfrm>
+          <a:prstGeom prst="rect">
+            <a:avLst/>
+          </a:prstGeom>
+          <a:noFill/>
+        </p:spPr>
+        <p:txBody>
+          <a:bodyPr wrap="square">
+            <a:spAutoFit/>
+          </a:bodyPr>
+          <a:lstStyle/>
+          <a:p>
+            <a:pPr>
+              <a:defRPr sz="1100" b="1">
                 <a:solidFill>
                   <a:srgbClr val="10B981"/>
                 </a:solidFill>
               </a:defRPr>
             </a:pPr>
             <a:r>
-              <a:t>Direct Contact Action</a:t>
-            </a:r>
-          </a:p>
-          <a:p>
-            <a:pPr>
-              <a:defRPr sz="1100">
-                <a:solidFill>
-                  <a:srgbClr val="0F172A"/>
-                </a:solidFill>
-              </a:defRPr>
-            </a:pPr>
-            <a:r>
-              <a:t>• For registered platform creators, the contact email is displayed with 1-click mailto: and copy actions.</a:t>
-            </a:r>
-          </a:p>
-          <a:p>
-            <a:pPr>
-              <a:defRPr sz="1100">
-                <a:solidFill>
-                  <a:srgbClr val="0F172A"/>
-                </a:solidFill>
-              </a:defRPr>
-            </a:pPr>
-            <a:r>
-              <a:t>• Zero middleman commission: brands contact creators directly.</a:t>
-            </a:r>
-          </a:p>
-          <a:p>
-            <a:pPr>
-              <a:defRPr sz="1100">
-                <a:solidFill>
-                  <a:srgbClr val="0F172A"/>
-                </a:solidFill>
-              </a:defRPr>
-            </a:pPr>
-            <a:r>
-              <a:t>• Unregistered creators show YouTube channel links for manual outreach.</a:t>
+              <a:t>Step 4: Campaign Input</a:t>
+            </a:r>
+          </a:p>
+          <a:p>
+            <a:pPr>
+              <a:defRPr sz="1000">
+                <a:solidFill>
+                  <a:srgbClr val="64748B"/>
+                </a:solidFill>
+              </a:defRPr>
+            </a:pPr>
+            <a:r>
+              <a:t>Defines budget, category, country, goal, and brief text.</a:t>
+            </a:r>
+          </a:p>
+        </p:txBody>
+      </p:sp>
+      <p:sp>
+        <p:nvSpPr>
+          <p:cNvPr id="14" name="Rounded Rectangle 13"/>
+          <p:cNvSpPr/>
+          <p:nvPr/>
+        </p:nvSpPr>
+        <p:spPr>
+          <a:xfrm>
+            <a:off x="9436608" y="4572000"/>
+            <a:ext cx="2057400" cy="1737360"/>
+          </a:xfrm>
+          <a:prstGeom prst="roundRect">
+            <a:avLst/>
+          </a:prstGeom>
+          <a:solidFill>
+            <a:srgbClr val="FFFFFF"/>
+          </a:solidFill>
+          <a:ln w="12700">
+            <a:solidFill>
+              <a:srgbClr val="E2E8F0"/>
+            </a:solidFill>
+          </a:ln>
+        </p:spPr>
+        <p:style>
+          <a:lnRef idx="1">
+            <a:schemeClr val="accent1"/>
+          </a:lnRef>
+          <a:fillRef idx="3">
+            <a:schemeClr val="accent1"/>
+          </a:fillRef>
+          <a:effectRef idx="2">
+            <a:schemeClr val="accent1"/>
+          </a:effectRef>
+          <a:fontRef idx="minor">
+            <a:schemeClr val="lt1"/>
+          </a:fontRef>
+        </p:style>
+        <p:txBody>
+          <a:bodyPr rtlCol="0" anchor="ctr"/>
+          <a:lstStyle/>
+          <a:p>
+            <a:pPr algn="ctr"/>
+          </a:p>
+        </p:txBody>
+      </p:sp>
+      <p:sp>
+        <p:nvSpPr>
+          <p:cNvPr id="15" name="TextBox 14"/>
+          <p:cNvSpPr txBox="1"/>
+          <p:nvPr/>
+        </p:nvSpPr>
+        <p:spPr>
+          <a:xfrm>
+            <a:off x="9528048" y="4709160"/>
+            <a:ext cx="1874519" cy="1463040"/>
+          </a:xfrm>
+          <a:prstGeom prst="rect">
+            <a:avLst/>
+          </a:prstGeom>
+          <a:noFill/>
+        </p:spPr>
+        <p:txBody>
+          <a:bodyPr wrap="square">
+            <a:spAutoFit/>
+          </a:bodyPr>
+          <a:lstStyle/>
+          <a:p>
+            <a:pPr>
+              <a:defRPr sz="1100" b="1">
+                <a:solidFill>
+                  <a:srgbClr val="4F46E5"/>
+                </a:solidFill>
+              </a:defRPr>
+            </a:pPr>
+            <a:r>
+              <a:t>Step 5: Recommendations</a:t>
+            </a:r>
+          </a:p>
+          <a:p>
+            <a:pPr>
+              <a:defRPr sz="1000">
+                <a:solidFill>
+                  <a:srgbClr val="64748B"/>
+                </a:solidFill>
+              </a:defRPr>
+            </a:pPr>
+            <a:r>
+              <a:t>Receives ranked creator cards with direct email contact.</a:t>
             </a:r>
           </a:p>
         </p:txBody>
@@ -8261,7 +7359,7 @@
               </a:defRPr>
             </a:pPr>
             <a:r>
-              <a:t>Project Work Distribution &amp; Current Progress</a:t>
+              <a:t>Platform Interface Showcase: React + Material-UI Frontend</a:t>
             </a:r>
           </a:p>
         </p:txBody>
@@ -8311,16 +7409,40 @@
           </a:p>
         </p:txBody>
       </p:sp>
-      <p:sp>
-        <p:nvSpPr>
-          <p:cNvPr id="5" name="TextBox 4"/>
+      <p:pic>
+        <p:nvPicPr>
+          <p:cNvPr id="5" name="Picture 4" descr="image2.jpg"/>
+          <p:cNvPicPr>
+            <a:picLocks noChangeAspect="1"/>
+          </p:cNvPicPr>
+          <p:nvPr/>
+        </p:nvPicPr>
+        <p:blipFill>
+          <a:blip r:embed="rId2"/>
+          <a:stretch>
+            <a:fillRect/>
+          </a:stretch>
+        </p:blipFill>
+        <p:spPr>
+          <a:xfrm>
+            <a:off x="914400" y="1645920"/>
+            <a:ext cx="3063240" cy="1719243"/>
+          </a:xfrm>
+          <a:prstGeom prst="rect">
+            <a:avLst/>
+          </a:prstGeom>
+        </p:spPr>
+      </p:pic>
+      <p:sp>
+        <p:nvSpPr>
+          <p:cNvPr id="6" name="TextBox 5"/>
           <p:cNvSpPr txBox="1"/>
           <p:nvPr/>
         </p:nvSpPr>
         <p:spPr>
           <a:xfrm>
-            <a:off x="914400" y="1645920"/>
-            <a:ext cx="3063240" cy="4480560"/>
+            <a:off x="914400" y="4937760"/>
+            <a:ext cx="3063240" cy="1280160"/>
           </a:xfrm>
           <a:prstGeom prst="rect">
             <a:avLst/>
@@ -8334,93 +7456,33 @@
           <a:lstStyle/>
           <a:p>
             <a:pPr>
-              <a:defRPr sz="1300" b="1">
+              <a:defRPr sz="1200" b="1">
                 <a:solidFill>
                   <a:srgbClr val="4F46E5"/>
                 </a:solidFill>
               </a:defRPr>
             </a:pPr>
             <a:r>
-              <a:t>Yashvi Bhadani (24DIT004)</a:t>
-            </a:r>
-          </a:p>
-          <a:p>
-            <a:pPr>
-              <a:defRPr sz="900" b="1">
+              <a:t>Landing &amp; Value Proposition</a:t>
+            </a:r>
+          </a:p>
+          <a:p>
+            <a:pPr>
+              <a:defRPr sz="1000">
                 <a:solidFill>
                   <a:srgbClr val="64748B"/>
                 </a:solidFill>
               </a:defRPr>
             </a:pPr>
             <a:r>
-              <a:t>DATA ENGINEERING &amp; PIPELINE</a:t>
-            </a:r>
-          </a:p>
-          <a:p>
-            <a:pPr>
-              <a:defRPr sz="1100">
-                <a:solidFill>
-                  <a:srgbClr val="0F172A"/>
-                </a:solidFill>
-              </a:defRPr>
-            </a:pPr>
-            <a:r>
-              <a:t>✔ YouTube Data API v3 integration pipeline</a:t>
-            </a:r>
-          </a:p>
-          <a:p>
-            <a:pPr>
-              <a:defRPr sz="1100">
-                <a:solidFill>
-                  <a:srgbClr val="0F172A"/>
-                </a:solidFill>
-              </a:defRPr>
-            </a:pPr>
-            <a:r>
-              <a:t>✔ Ingested 2,000+ channels and 2,841+ videos</a:t>
-            </a:r>
-          </a:p>
-          <a:p>
-            <a:pPr>
-              <a:defRPr sz="1100">
-                <a:solidFill>
-                  <a:srgbClr val="0F172A"/>
-                </a:solidFill>
-              </a:defRPr>
-            </a:pPr>
-            <a:r>
-              <a:t>✔ MongoDB raw layer architecture &amp; schemas</a:t>
-            </a:r>
-          </a:p>
-          <a:p>
-            <a:pPr>
-              <a:defRPr sz="1100">
-                <a:solidFill>
-                  <a:srgbClr val="0F172A"/>
-                </a:solidFill>
-              </a:defRPr>
-            </a:pPr>
-            <a:r>
-              <a:t>✔ Automated background ingestion tasks</a:t>
-            </a:r>
-          </a:p>
-          <a:p>
-            <a:pPr>
-              <a:defRPr sz="1100">
-                <a:solidFill>
-                  <a:srgbClr val="0F172A"/>
-                </a:solidFill>
-              </a:defRPr>
-            </a:pPr>
-            <a:r>
-              <a:t>→ Feature engineering &amp; data hygiene</a:t>
-            </a:r>
-          </a:p>
-        </p:txBody>
-      </p:sp>
-      <p:sp>
-        <p:nvSpPr>
-          <p:cNvPr id="6" name="Rounded Rectangle 5"/>
+              <a:t>Clean hero section introducing semantic influencer intelligence.</a:t>
+            </a:r>
+          </a:p>
+        </p:txBody>
+      </p:sp>
+      <p:sp>
+        <p:nvSpPr>
+          <p:cNvPr id="7" name="Rounded Rectangle 6"/>
           <p:cNvSpPr/>
           <p:nvPr/>
         </p:nvSpPr>
@@ -8463,16 +7525,40 @@
           </a:p>
         </p:txBody>
       </p:sp>
-      <p:sp>
-        <p:nvSpPr>
-          <p:cNvPr id="7" name="TextBox 6"/>
+      <p:pic>
+        <p:nvPicPr>
+          <p:cNvPr id="8" name="Picture 7" descr="image4.jpg"/>
+          <p:cNvPicPr>
+            <a:picLocks noChangeAspect="1"/>
+          </p:cNvPicPr>
+          <p:nvPr/>
+        </p:nvPicPr>
+        <p:blipFill>
+          <a:blip r:embed="rId3"/>
+          <a:stretch>
+            <a:fillRect/>
+          </a:stretch>
+        </p:blipFill>
+        <p:spPr>
+          <a:xfrm>
+            <a:off x="4526280" y="1645920"/>
+            <a:ext cx="3063240" cy="1721158"/>
+          </a:xfrm>
+          <a:prstGeom prst="rect">
+            <a:avLst/>
+          </a:prstGeom>
+        </p:spPr>
+      </p:pic>
+      <p:sp>
+        <p:nvSpPr>
+          <p:cNvPr id="9" name="TextBox 8"/>
           <p:cNvSpPr txBox="1"/>
           <p:nvPr/>
         </p:nvSpPr>
         <p:spPr>
           <a:xfrm>
-            <a:off x="4526280" y="1645920"/>
-            <a:ext cx="3063240" cy="4480560"/>
+            <a:off x="4526280" y="4937760"/>
+            <a:ext cx="3063240" cy="1280160"/>
           </a:xfrm>
           <a:prstGeom prst="rect">
             <a:avLst/>
@@ -8486,93 +7572,33 @@
           <a:lstStyle/>
           <a:p>
             <a:pPr>
-              <a:defRPr sz="1300" b="1">
-                <a:solidFill>
-                  <a:srgbClr val="7C3AED"/>
-                </a:solidFill>
-              </a:defRPr>
-            </a:pPr>
-            <a:r>
-              <a:t>Shivansh (24DIT014)</a:t>
-            </a:r>
-          </a:p>
-          <a:p>
-            <a:pPr>
-              <a:defRPr sz="900" b="1">
+              <a:defRPr sz="1200" b="1">
+                <a:solidFill>
+                  <a:srgbClr val="4F46E5"/>
+                </a:solidFill>
+              </a:defRPr>
+            </a:pPr>
+            <a:r>
+              <a:t>Secure Supabase Authentication</a:t>
+            </a:r>
+          </a:p>
+          <a:p>
+            <a:pPr>
+              <a:defRPr sz="1000">
                 <a:solidFill>
                   <a:srgbClr val="64748B"/>
                 </a:solidFill>
               </a:defRPr>
             </a:pPr>
             <a:r>
-              <a:t>UI/UX &amp; NLP ENGINE</a:t>
-            </a:r>
-          </a:p>
-          <a:p>
-            <a:pPr>
-              <a:defRPr sz="1100">
-                <a:solidFill>
-                  <a:srgbClr val="0F172A"/>
-                </a:solidFill>
-              </a:defRPr>
-            </a:pPr>
-            <a:r>
-              <a:t>✔ Complete Figma design system &amp; layouts</a:t>
-            </a:r>
-          </a:p>
-          <a:p>
-            <a:pPr>
-              <a:defRPr sz="1100">
-                <a:solidFill>
-                  <a:srgbClr val="0F172A"/>
-                </a:solidFill>
-              </a:defRPr>
-            </a:pPr>
-            <a:r>
-              <a:t>✔ React 19 + MUI responsive application</a:t>
-            </a:r>
-          </a:p>
-          <a:p>
-            <a:pPr>
-              <a:defRPr sz="1100">
-                <a:solidFill>
-                  <a:srgbClr val="0F172A"/>
-                </a:solidFill>
-              </a:defRPr>
-            </a:pPr>
-            <a:r>
-              <a:t>✔ Sentence-BERT all-MiniLM-L6-v2 integration</a:t>
-            </a:r>
-          </a:p>
-          <a:p>
-            <a:pPr>
-              <a:defRPr sz="1100">
-                <a:solidFill>
-                  <a:srgbClr val="0F172A"/>
-                </a:solidFill>
-              </a:defRPr>
-            </a:pPr>
-            <a:r>
-              <a:t>✔ Cosine similarity tensor calculation</a:t>
-            </a:r>
-          </a:p>
-          <a:p>
-            <a:pPr>
-              <a:defRPr sz="1100">
-                <a:solidFill>
-                  <a:srgbClr val="0F172A"/>
-                </a:solidFill>
-              </a:defRPr>
-            </a:pPr>
-            <a:r>
-              <a:t>→ Graph network modeling &amp; visualization</a:t>
-            </a:r>
-          </a:p>
-        </p:txBody>
-      </p:sp>
-      <p:sp>
-        <p:nvSpPr>
-          <p:cNvPr id="8" name="Rounded Rectangle 7"/>
+              <a:t>Dual-role authentication supporting Brand Partners and Creators.</a:t>
+            </a:r>
+          </a:p>
+        </p:txBody>
+      </p:sp>
+      <p:sp>
+        <p:nvSpPr>
+          <p:cNvPr id="10" name="Rounded Rectangle 9"/>
           <p:cNvSpPr/>
           <p:nvPr/>
         </p:nvSpPr>
@@ -8615,16 +7641,40 @@
           </a:p>
         </p:txBody>
       </p:sp>
-      <p:sp>
-        <p:nvSpPr>
-          <p:cNvPr id="9" name="TextBox 8"/>
+      <p:pic>
+        <p:nvPicPr>
+          <p:cNvPr id="11" name="Picture 10" descr="image3.jpg"/>
+          <p:cNvPicPr>
+            <a:picLocks noChangeAspect="1"/>
+          </p:cNvPicPr>
+          <p:nvPr/>
+        </p:nvPicPr>
+        <p:blipFill>
+          <a:blip r:embed="rId4"/>
+          <a:stretch>
+            <a:fillRect/>
+          </a:stretch>
+        </p:blipFill>
+        <p:spPr>
+          <a:xfrm>
+            <a:off x="8138160" y="1645920"/>
+            <a:ext cx="3063240" cy="1721158"/>
+          </a:xfrm>
+          <a:prstGeom prst="rect">
+            <a:avLst/>
+          </a:prstGeom>
+        </p:spPr>
+      </p:pic>
+      <p:sp>
+        <p:nvSpPr>
+          <p:cNvPr id="12" name="TextBox 11"/>
           <p:cNvSpPr txBox="1"/>
           <p:nvPr/>
         </p:nvSpPr>
         <p:spPr>
           <a:xfrm>
-            <a:off x="8138160" y="1645920"/>
-            <a:ext cx="3063240" cy="4480560"/>
+            <a:off x="8138160" y="4937760"/>
+            <a:ext cx="3063240" cy="1280160"/>
           </a:xfrm>
           <a:prstGeom prst="rect">
             <a:avLst/>
@@ -8638,86 +7688,26 @@
           <a:lstStyle/>
           <a:p>
             <a:pPr>
-              <a:defRPr sz="1300" b="1">
-                <a:solidFill>
-                  <a:srgbClr val="0284C7"/>
-                </a:solidFill>
-              </a:defRPr>
-            </a:pPr>
-            <a:r>
-              <a:t>Astha Makwana (24DIT030)</a:t>
-            </a:r>
-          </a:p>
-          <a:p>
-            <a:pPr>
-              <a:defRPr sz="900" b="1">
+              <a:defRPr sz="1200" b="1">
+                <a:solidFill>
+                  <a:srgbClr val="4F46E5"/>
+                </a:solidFill>
+              </a:defRPr>
+            </a:pPr>
+            <a:r>
+              <a:t>Campaign Creation Dashboard</a:t>
+            </a:r>
+          </a:p>
+          <a:p>
+            <a:pPr>
+              <a:defRPr sz="1000">
                 <a:solidFill>
                   <a:srgbClr val="64748B"/>
                 </a:solidFill>
               </a:defRPr>
             </a:pPr>
             <a:r>
-              <a:t>SUPABASE DATABASE &amp; ML PREP</a:t>
-            </a:r>
-          </a:p>
-          <a:p>
-            <a:pPr>
-              <a:defRPr sz="1100">
-                <a:solidFill>
-                  <a:srgbClr val="0F172A"/>
-                </a:solidFill>
-              </a:defRPr>
-            </a:pPr>
-            <a:r>
-              <a:t>✔ Supabase PostgreSQL relational schemas</a:t>
-            </a:r>
-          </a:p>
-          <a:p>
-            <a:pPr>
-              <a:defRPr sz="1100">
-                <a:solidFill>
-                  <a:srgbClr val="0F172A"/>
-                </a:solidFill>
-              </a:defRPr>
-            </a:pPr>
-            <a:r>
-              <a:t>✔ Client &amp; Server Supabase Auth (JWT Bearer)</a:t>
-            </a:r>
-          </a:p>
-          <a:p>
-            <a:pPr>
-              <a:defRPr sz="1100">
-                <a:solidFill>
-                  <a:srgbClr val="0F172A"/>
-                </a:solidFill>
-              </a:defRPr>
-            </a:pPr>
-            <a:r>
-              <a:t>✔ Row-Level Security (RLS) &amp; Public Views</a:t>
-            </a:r>
-          </a:p>
-          <a:p>
-            <a:pPr>
-              <a:defRPr sz="1100">
-                <a:solidFill>
-                  <a:srgbClr val="0F172A"/>
-                </a:solidFill>
-              </a:defRPr>
-            </a:pPr>
-            <a:r>
-              <a:t>✔ registered_channels table &amp; Zero N+1 query</a:t>
-            </a:r>
-          </a:p>
-          <a:p>
-            <a:pPr>
-              <a:defRPr sz="1100">
-                <a:solidFill>
-                  <a:srgbClr val="0F172A"/>
-                </a:solidFill>
-              </a:defRPr>
-            </a:pPr>
-            <a:r>
-              <a:t>→ Model tuning &amp; offline ranking evaluation</a:t>
+              <a:t>Intuitive input matrix for category, budget, location, and brief.</a:t>
             </a:r>
           </a:p>
         </p:txBody>
@@ -8813,7 +7803,7 @@
               </a:defRPr>
             </a:pPr>
             <a:r>
-              <a:t>Current Implementation Status &amp; Future Roadmap</a:t>
+              <a:t>Explainable AI: Why Was This Creator Recommended?</a:t>
             </a:r>
           </a:p>
         </p:txBody>
@@ -8827,7 +7817,7 @@
         <p:spPr>
           <a:xfrm>
             <a:off x="731520" y="1463040"/>
-            <a:ext cx="5120640" cy="4846320"/>
+            <a:ext cx="5257800" cy="2240280"/>
           </a:xfrm>
           <a:prstGeom prst="roundRect">
             <a:avLst/>
@@ -8872,7 +7862,7 @@
         <p:spPr>
           <a:xfrm>
             <a:off x="914400" y="1645920"/>
-            <a:ext cx="4754880" cy="4480560"/>
+            <a:ext cx="4892040" cy="1874519"/>
           </a:xfrm>
           <a:prstGeom prst="rect">
             <a:avLst/>
@@ -8886,134 +7876,50 @@
           <a:lstStyle/>
           <a:p>
             <a:pPr>
-              <a:defRPr sz="1500" b="1">
-                <a:solidFill>
-                  <a:srgbClr val="10B981"/>
-                </a:solidFill>
-              </a:defRPr>
-            </a:pPr>
-            <a:r>
-              <a:t>Completed &amp; Live in Current Build</a:t>
-            </a:r>
-          </a:p>
-          <a:p>
-            <a:pPr>
-              <a:defRPr sz="1100" b="1">
-                <a:solidFill>
-                  <a:srgbClr val="0F172A"/>
-                </a:solidFill>
-              </a:defRPr>
-            </a:pPr>
-            <a:r>
-              <a:t>✔ Full-Stack Integration:</a:t>
-            </a:r>
-          </a:p>
-          <a:p>
-            <a:pPr>
-              <a:defRPr sz="1000">
-                <a:solidFill>
-                  <a:srgbClr val="64748B"/>
-                </a:solidFill>
-              </a:defRPr>
-            </a:pPr>
-            <a:r>
-              <a:t>   React frontend, Express gateway, and FastAPI AI engine running simultaneously with zero CORS errors.</a:t>
-            </a:r>
-          </a:p>
-          <a:p>
-            <a:pPr>
-              <a:defRPr sz="1100" b="1">
-                <a:solidFill>
-                  <a:srgbClr val="0F172A"/>
-                </a:solidFill>
-              </a:defRPr>
-            </a:pPr>
-            <a:r>
-              <a:t>✔ Supabase Auth &amp; RLS:</a:t>
-            </a:r>
-          </a:p>
-          <a:p>
-            <a:pPr>
-              <a:defRPr sz="1000">
-                <a:solidFill>
-                  <a:srgbClr val="64748B"/>
-                </a:solidFill>
-              </a:defRPr>
-            </a:pPr>
-            <a:r>
-              <a:t>   Dual-role signup, session persistence with onAuthStateChange, and protected FastAPI endpoints.</a:t>
-            </a:r>
-          </a:p>
-          <a:p>
-            <a:pPr>
-              <a:defRPr sz="1100" b="1">
-                <a:solidFill>
-                  <a:srgbClr val="0F172A"/>
-                </a:solidFill>
-              </a:defRPr>
-            </a:pPr>
-            <a:r>
-              <a:t>✔ Live SBERT Recommender:</a:t>
-            </a:r>
-          </a:p>
-          <a:p>
-            <a:pPr>
-              <a:defRPr sz="1000">
-                <a:solidFill>
-                  <a:srgbClr val="64748B"/>
-                </a:solidFill>
-              </a:defRPr>
-            </a:pPr>
-            <a:r>
-              <a:t>   Campaign briefs generate instant ranked recommendations with real similarity and engagement scores.</a:t>
-            </a:r>
-          </a:p>
-          <a:p>
-            <a:pPr>
-              <a:defRPr sz="1100" b="1">
-                <a:solidFill>
-                  <a:srgbClr val="0F172A"/>
-                </a:solidFill>
-              </a:defRPr>
-            </a:pPr>
-            <a:r>
-              <a:t>✔ Creator Registration Page:</a:t>
-            </a:r>
-          </a:p>
-          <a:p>
-            <a:pPr>
-              <a:defRPr sz="1000">
-                <a:solidFill>
-                  <a:srgbClr val="64748B"/>
-                </a:solidFill>
-              </a:defRPr>
-            </a:pPr>
-            <a:r>
-              <a:t>   Creators register YouTube IDs/handles; background ingestion syncs channel into ml_data.channels in real time.</a:t>
-            </a:r>
-          </a:p>
-          <a:p>
-            <a:pPr>
-              <a:defRPr sz="1100" b="1">
-                <a:solidFill>
-                  <a:srgbClr val="0F172A"/>
-                </a:solidFill>
-              </a:defRPr>
-            </a:pPr>
-            <a:r>
-              <a:t>✔ Zero N+1 Public Email Sync:</a:t>
-            </a:r>
-          </a:p>
-          <a:p>
-            <a:pPr>
-              <a:defRPr sz="1000">
-                <a:solidFill>
-                  <a:srgbClr val="64748B"/>
-                </a:solidFill>
-              </a:defRPr>
-            </a:pPr>
-            <a:r>
-              <a:t>   Single batched query maps contact emails to recommendations.</a:t>
+              <a:defRPr sz="1300" b="1">
+                <a:solidFill>
+                  <a:srgbClr val="4F46E5"/>
+                </a:solidFill>
+              </a:defRPr>
+            </a:pPr>
+            <a:r>
+              <a:t>Semantic Match Breakdown</a:t>
+            </a:r>
+          </a:p>
+          <a:p>
+            <a:pPr>
+              <a:defRPr sz="1100">
+                <a:solidFill>
+                  <a:srgbClr val="0F172A"/>
+                </a:solidFill>
+              </a:defRPr>
+            </a:pPr>
+            <a:r>
+              <a:t>• Displays exact semantic similarity percentage (e.g. 84% Match).</a:t>
+            </a:r>
+          </a:p>
+          <a:p>
+            <a:pPr>
+              <a:defRPr sz="1100">
+                <a:solidFill>
+                  <a:srgbClr val="0F172A"/>
+                </a:solidFill>
+              </a:defRPr>
+            </a:pPr>
+            <a:r>
+              <a:t>• Explains the contextual connection between creator's recent video themes and campaign keywords.</a:t>
+            </a:r>
+          </a:p>
+          <a:p>
+            <a:pPr>
+              <a:defRPr sz="1100">
+                <a:solidFill>
+                  <a:srgbClr val="0F172A"/>
+                </a:solidFill>
+              </a:defRPr>
+            </a:pPr>
+            <a:r>
+              <a:t>• Eliminates 'black-box' recommendations so marketing teams understand the match rationale.</a:t>
             </a:r>
           </a:p>
         </p:txBody>
@@ -9026,8 +7932,8 @@
         </p:nvSpPr>
         <p:spPr>
           <a:xfrm>
-            <a:off x="6217920" y="1463040"/>
-            <a:ext cx="5212080" cy="4846320"/>
+            <a:off x="6172200" y="1463040"/>
+            <a:ext cx="5257800" cy="2240280"/>
           </a:xfrm>
           <a:prstGeom prst="roundRect">
             <a:avLst/>
@@ -9071,8 +7977,8 @@
         </p:nvSpPr>
         <p:spPr>
           <a:xfrm>
-            <a:off x="6400800" y="1645920"/>
-            <a:ext cx="4846320" cy="4480560"/>
+            <a:off x="6355080" y="1645920"/>
+            <a:ext cx="4892040" cy="1874519"/>
           </a:xfrm>
           <a:prstGeom prst="rect">
             <a:avLst/>
@@ -9086,110 +7992,282 @@
           <a:lstStyle/>
           <a:p>
             <a:pPr>
-              <a:defRPr sz="1500" b="1">
-                <a:solidFill>
-                  <a:srgbClr val="4F46E5"/>
-                </a:solidFill>
-              </a:defRPr>
-            </a:pPr>
-            <a:r>
-              <a:t>Future Technical Roadmap (Semester 6)</a:t>
-            </a:r>
-          </a:p>
-          <a:p>
-            <a:pPr>
-              <a:defRPr sz="1100" b="1">
-                <a:solidFill>
-                  <a:srgbClr val="0F172A"/>
-                </a:solidFill>
-              </a:defRPr>
-            </a:pPr>
-            <a:r>
-              <a:t>→ Graph-Based Authority Analysis:</a:t>
-            </a:r>
-          </a:p>
-          <a:p>
-            <a:pPr>
-              <a:defRPr sz="1000">
-                <a:solidFill>
-                  <a:srgbClr val="64748B"/>
-                </a:solidFill>
-              </a:defRPr>
-            </a:pPr>
-            <a:r>
-              <a:t>   Construct creator co-mention networks and calculate PageRank and Betweenness Centrality for community hubs.</a:t>
-            </a:r>
-          </a:p>
-          <a:p>
-            <a:pPr>
-              <a:defRPr sz="1100" b="1">
-                <a:solidFill>
-                  <a:srgbClr val="0F172A"/>
-                </a:solidFill>
-              </a:defRPr>
-            </a:pPr>
-            <a:r>
-              <a:t>→ Google OAuth Channel Ownership:</a:t>
-            </a:r>
-          </a:p>
-          <a:p>
-            <a:pPr>
-              <a:defRPr sz="1000">
-                <a:solidFill>
-                  <a:srgbClr val="64748B"/>
-                </a:solidFill>
-              </a:defRPr>
-            </a:pPr>
-            <a:r>
-              <a:t>   Implement youtube.readonly OAuth scope (channels.list mine=true) to cryptographically verify channel ownership.</a:t>
-            </a:r>
-          </a:p>
-          <a:p>
-            <a:pPr>
-              <a:defRPr sz="1100" b="1">
-                <a:solidFill>
-                  <a:srgbClr val="0F172A"/>
-                </a:solidFill>
-              </a:defRPr>
-            </a:pPr>
-            <a:r>
-              <a:t>→ Cross-Platform Expansion:</a:t>
-            </a:r>
-          </a:p>
-          <a:p>
-            <a:pPr>
-              <a:defRPr sz="1000">
-                <a:solidFill>
-                  <a:srgbClr val="64748B"/>
-                </a:solidFill>
-              </a:defRPr>
-            </a:pPr>
-            <a:r>
-              <a:t>   Ingest Instagram Reels and TikTok creator metrics alongside YouTube Data API.</a:t>
-            </a:r>
-          </a:p>
-          <a:p>
-            <a:pPr>
-              <a:defRPr sz="1100" b="1">
-                <a:solidFill>
-                  <a:srgbClr val="0F172A"/>
-                </a:solidFill>
-              </a:defRPr>
-            </a:pPr>
-            <a:r>
-              <a:t>→ Offline Model Evaluation:</a:t>
-            </a:r>
-          </a:p>
-          <a:p>
-            <a:pPr>
-              <a:defRPr sz="1000">
-                <a:solidFill>
-                  <a:srgbClr val="64748B"/>
-                </a:solidFill>
-              </a:defRPr>
-            </a:pPr>
-            <a:r>
-              <a:t>   Benchmark ranking quality with NDCG@10 (Normalized Discounted Cumulative Gain) and Mean Reciprocal Rank (MRR).</a:t>
+              <a:defRPr sz="1300" b="1">
+                <a:solidFill>
+                  <a:srgbClr val="7C3AED"/>
+                </a:solidFill>
+              </a:defRPr>
+            </a:pPr>
+            <a:r>
+              <a:t>Engagement Quality Index</a:t>
+            </a:r>
+          </a:p>
+          <a:p>
+            <a:pPr>
+              <a:defRPr sz="1100">
+                <a:solidFill>
+                  <a:srgbClr val="0F172A"/>
+                </a:solidFill>
+              </a:defRPr>
+            </a:pPr>
+            <a:r>
+              <a:t>• Transparently reports audience engagement rate (e.g. 4.82% ER).</a:t>
+            </a:r>
+          </a:p>
+          <a:p>
+            <a:pPr>
+              <a:defRPr sz="1100">
+                <a:solidFill>
+                  <a:srgbClr val="0F172A"/>
+                </a:solidFill>
+              </a:defRPr>
+            </a:pPr>
+            <a:r>
+              <a:t>• Shows normalized percentile ranking within their specific category.</a:t>
+            </a:r>
+          </a:p>
+          <a:p>
+            <a:pPr>
+              <a:defRPr sz="1100">
+                <a:solidFill>
+                  <a:srgbClr val="0F172A"/>
+                </a:solidFill>
+              </a:defRPr>
+            </a:pPr>
+            <a:r>
+              <a:t>• Verifies active recent viewership rather than dormant historical follower counts.</a:t>
+            </a:r>
+          </a:p>
+        </p:txBody>
+      </p:sp>
+      <p:sp>
+        <p:nvSpPr>
+          <p:cNvPr id="8" name="Rounded Rectangle 7"/>
+          <p:cNvSpPr/>
+          <p:nvPr/>
+        </p:nvSpPr>
+        <p:spPr>
+          <a:xfrm>
+            <a:off x="731520" y="3931920"/>
+            <a:ext cx="5257800" cy="2240280"/>
+          </a:xfrm>
+          <a:prstGeom prst="roundRect">
+            <a:avLst/>
+          </a:prstGeom>
+          <a:solidFill>
+            <a:srgbClr val="FFFFFF"/>
+          </a:solidFill>
+          <a:ln w="12700">
+            <a:solidFill>
+              <a:srgbClr val="E2E8F0"/>
+            </a:solidFill>
+          </a:ln>
+        </p:spPr>
+        <p:style>
+          <a:lnRef idx="1">
+            <a:schemeClr val="accent1"/>
+          </a:lnRef>
+          <a:fillRef idx="3">
+            <a:schemeClr val="accent1"/>
+          </a:fillRef>
+          <a:effectRef idx="2">
+            <a:schemeClr val="accent1"/>
+          </a:effectRef>
+          <a:fontRef idx="minor">
+            <a:schemeClr val="lt1"/>
+          </a:fontRef>
+        </p:style>
+        <p:txBody>
+          <a:bodyPr rtlCol="0" anchor="ctr"/>
+          <a:lstStyle/>
+          <a:p>
+            <a:pPr algn="ctr"/>
+          </a:p>
+        </p:txBody>
+      </p:sp>
+      <p:sp>
+        <p:nvSpPr>
+          <p:cNvPr id="9" name="TextBox 8"/>
+          <p:cNvSpPr txBox="1"/>
+          <p:nvPr/>
+        </p:nvSpPr>
+        <p:spPr>
+          <a:xfrm>
+            <a:off x="914400" y="4114800"/>
+            <a:ext cx="4892040" cy="1874519"/>
+          </a:xfrm>
+          <a:prstGeom prst="rect">
+            <a:avLst/>
+          </a:prstGeom>
+          <a:noFill/>
+        </p:spPr>
+        <p:txBody>
+          <a:bodyPr wrap="square">
+            <a:spAutoFit/>
+          </a:bodyPr>
+          <a:lstStyle/>
+          <a:p>
+            <a:pPr>
+              <a:defRPr sz="1300" b="1">
+                <a:solidFill>
+                  <a:srgbClr val="0284C7"/>
+                </a:solidFill>
+              </a:defRPr>
+            </a:pPr>
+            <a:r>
+              <a:t>Budget &amp; Creator Collab Fit</a:t>
+            </a:r>
+          </a:p>
+          <a:p>
+            <a:pPr>
+              <a:defRPr sz="1100">
+                <a:solidFill>
+                  <a:srgbClr val="0F172A"/>
+                </a:solidFill>
+              </a:defRPr>
+            </a:pPr>
+            <a:r>
+              <a:t>• Estimated collaboration cost calculated via standard Indian market formulas.</a:t>
+            </a:r>
+          </a:p>
+          <a:p>
+            <a:pPr>
+              <a:defRPr sz="1100">
+                <a:solidFill>
+                  <a:srgbClr val="0F172A"/>
+                </a:solidFill>
+              </a:defRPr>
+            </a:pPr>
+            <a:r>
+              <a:t>• Tier classification (Nano, Micro, Mid, Macro) explicitly identified.</a:t>
+            </a:r>
+          </a:p>
+          <a:p>
+            <a:pPr>
+              <a:defRPr sz="1100">
+                <a:solidFill>
+                  <a:srgbClr val="0F172A"/>
+                </a:solidFill>
+              </a:defRPr>
+            </a:pPr>
+            <a:r>
+              <a:t>• Confirms whether creator fee fits comfortably within campaign budget.</a:t>
+            </a:r>
+          </a:p>
+        </p:txBody>
+      </p:sp>
+      <p:sp>
+        <p:nvSpPr>
+          <p:cNvPr id="10" name="Rounded Rectangle 9"/>
+          <p:cNvSpPr/>
+          <p:nvPr/>
+        </p:nvSpPr>
+        <p:spPr>
+          <a:xfrm>
+            <a:off x="6172200" y="3931920"/>
+            <a:ext cx="5257800" cy="2240280"/>
+          </a:xfrm>
+          <a:prstGeom prst="roundRect">
+            <a:avLst/>
+          </a:prstGeom>
+          <a:solidFill>
+            <a:srgbClr val="FFFFFF"/>
+          </a:solidFill>
+          <a:ln w="12700">
+            <a:solidFill>
+              <a:srgbClr val="E2E8F0"/>
+            </a:solidFill>
+          </a:ln>
+        </p:spPr>
+        <p:style>
+          <a:lnRef idx="1">
+            <a:schemeClr val="accent1"/>
+          </a:lnRef>
+          <a:fillRef idx="3">
+            <a:schemeClr val="accent1"/>
+          </a:fillRef>
+          <a:effectRef idx="2">
+            <a:schemeClr val="accent1"/>
+          </a:effectRef>
+          <a:fontRef idx="minor">
+            <a:schemeClr val="lt1"/>
+          </a:fontRef>
+        </p:style>
+        <p:txBody>
+          <a:bodyPr rtlCol="0" anchor="ctr"/>
+          <a:lstStyle/>
+          <a:p>
+            <a:pPr algn="ctr"/>
+          </a:p>
+        </p:txBody>
+      </p:sp>
+      <p:sp>
+        <p:nvSpPr>
+          <p:cNvPr id="11" name="TextBox 10"/>
+          <p:cNvSpPr txBox="1"/>
+          <p:nvPr/>
+        </p:nvSpPr>
+        <p:spPr>
+          <a:xfrm>
+            <a:off x="6355080" y="4114800"/>
+            <a:ext cx="4892040" cy="1874519"/>
+          </a:xfrm>
+          <a:prstGeom prst="rect">
+            <a:avLst/>
+          </a:prstGeom>
+          <a:noFill/>
+        </p:spPr>
+        <p:txBody>
+          <a:bodyPr wrap="square">
+            <a:spAutoFit/>
+          </a:bodyPr>
+          <a:lstStyle/>
+          <a:p>
+            <a:pPr>
+              <a:defRPr sz="1300" b="1">
+                <a:solidFill>
+                  <a:srgbClr val="10B981"/>
+                </a:solidFill>
+              </a:defRPr>
+            </a:pPr>
+            <a:r>
+              <a:t>Direct Contact Action</a:t>
+            </a:r>
+          </a:p>
+          <a:p>
+            <a:pPr>
+              <a:defRPr sz="1100">
+                <a:solidFill>
+                  <a:srgbClr val="0F172A"/>
+                </a:solidFill>
+              </a:defRPr>
+            </a:pPr>
+            <a:r>
+              <a:t>• For registered platform creators, the contact email is displayed with 1-click mailto: and copy actions.</a:t>
+            </a:r>
+          </a:p>
+          <a:p>
+            <a:pPr>
+              <a:defRPr sz="1100">
+                <a:solidFill>
+                  <a:srgbClr val="0F172A"/>
+                </a:solidFill>
+              </a:defRPr>
+            </a:pPr>
+            <a:r>
+              <a:t>• Zero middleman commission: brands contact creators directly.</a:t>
+            </a:r>
+          </a:p>
+          <a:p>
+            <a:pPr>
+              <a:defRPr sz="1100">
+                <a:solidFill>
+                  <a:srgbClr val="0F172A"/>
+                </a:solidFill>
+              </a:defRPr>
+            </a:pPr>
+            <a:r>
+              <a:t>• Unregistered creators show YouTube channel links for manual outreach.</a:t>
             </a:r>
           </a:p>
         </p:txBody>
@@ -9208,7 +8286,7 @@
     <p:bg>
       <p:bgPr>
         <a:solidFill>
-          <a:srgbClr val="0F172A"/>
+          <a:srgbClr val="F8FAFC"/>
         </a:solidFill>
         <a:effectLst/>
       </p:bgPr>
@@ -9228,8 +8306,8 @@
         </p:nvSpPr>
         <p:spPr>
           <a:xfrm>
-            <a:off x="1371600" y="1645920"/>
-            <a:ext cx="9418320" cy="3657600"/>
+            <a:off x="731520" y="365760"/>
+            <a:ext cx="10698480" cy="365760"/>
           </a:xfrm>
           <a:prstGeom prst="rect">
             <a:avLst/>
@@ -9242,61 +8320,978 @@
           </a:bodyPr>
           <a:lstStyle/>
           <a:p>
-            <a:pPr algn="ctr">
-              <a:defRPr sz="4000" b="1">
-                <a:solidFill>
-                  <a:srgbClr val="FFFFFF"/>
-                </a:solidFill>
-              </a:defRPr>
-            </a:pPr>
-            <a:r>
-              <a:t>InfluenceAI</a:t>
-            </a:r>
-          </a:p>
-          <a:p>
-            <a:pPr algn="ctr">
-              <a:defRPr sz="1800">
+            <a:pPr>
+              <a:defRPr sz="1000" b="1">
                 <a:solidFill>
                   <a:srgbClr val="4F46E5"/>
                 </a:solidFill>
               </a:defRPr>
             </a:pPr>
             <a:r>
-              <a:t>From Unfiltered Search to Intelligent, Explainable Recommendation</a:t>
-            </a:r>
-          </a:p>
-          <a:p>
-            <a:br/>
-            <a:pPr algn="ctr">
-              <a:defRPr sz="1500">
-                <a:solidFill>
-                  <a:srgbClr val="CBD5E1"/>
-                </a:solidFill>
-              </a:defRPr>
-            </a:pPr>
-            <a:r>
-              <a:t>Thank you for your valuable guidance and attention.</a:t>
-            </a:r>
-            <a:br/>
-            <a:r>
-              <a:t>We welcome your questions and feedback.</a:t>
-            </a:r>
-          </a:p>
-          <a:p>
-            <a:br/>
-            <a:pPr algn="ctr">
-              <a:defRPr sz="1200">
-                <a:solidFill>
-                  <a:srgbClr val="94A3B8"/>
-                </a:solidFill>
-              </a:defRPr>
-            </a:pPr>
-            <a:r>
-              <a:t>24DIT004 (Yashvi)  ·  24DIT014 (Shivansh)  ·  24DIT030 (Astha)</a:t>
-            </a:r>
-            <a:br/>
-            <a:r>
-              <a:t>CHARUSAT  ·  DEPSTAR  ·  IT Dept</a:t>
+              <a:t>INFLUENCEAI — AI-POWERED RECOMMENDATION SYSTEM</a:t>
+            </a:r>
+          </a:p>
+        </p:txBody>
+      </p:sp>
+      <p:sp>
+        <p:nvSpPr>
+          <p:cNvPr id="3" name="TextBox 2"/>
+          <p:cNvSpPr txBox="1"/>
+          <p:nvPr/>
+        </p:nvSpPr>
+        <p:spPr>
+          <a:xfrm>
+            <a:off x="731520" y="640080"/>
+            <a:ext cx="10698480" cy="731520"/>
+          </a:xfrm>
+          <a:prstGeom prst="rect">
+            <a:avLst/>
+          </a:prstGeom>
+          <a:noFill/>
+        </p:spPr>
+        <p:txBody>
+          <a:bodyPr wrap="square">
+            <a:spAutoFit/>
+          </a:bodyPr>
+          <a:lstStyle/>
+          <a:p>
+            <a:pPr>
+              <a:defRPr sz="2200" b="1">
+                <a:solidFill>
+                  <a:srgbClr val="0F172A"/>
+                </a:solidFill>
+              </a:defRPr>
+            </a:pPr>
+            <a:r>
+              <a:t>Project Work Distribution &amp; Current Progress</a:t>
+            </a:r>
+          </a:p>
+        </p:txBody>
+      </p:sp>
+      <p:sp>
+        <p:nvSpPr>
+          <p:cNvPr id="4" name="Rounded Rectangle 3"/>
+          <p:cNvSpPr/>
+          <p:nvPr/>
+        </p:nvSpPr>
+        <p:spPr>
+          <a:xfrm>
+            <a:off x="731520" y="1463040"/>
+            <a:ext cx="3429000" cy="4846320"/>
+          </a:xfrm>
+          <a:prstGeom prst="roundRect">
+            <a:avLst/>
+          </a:prstGeom>
+          <a:solidFill>
+            <a:srgbClr val="FFFFFF"/>
+          </a:solidFill>
+          <a:ln w="12700">
+            <a:solidFill>
+              <a:srgbClr val="E2E8F0"/>
+            </a:solidFill>
+          </a:ln>
+        </p:spPr>
+        <p:style>
+          <a:lnRef idx="1">
+            <a:schemeClr val="accent1"/>
+          </a:lnRef>
+          <a:fillRef idx="3">
+            <a:schemeClr val="accent1"/>
+          </a:fillRef>
+          <a:effectRef idx="2">
+            <a:schemeClr val="accent1"/>
+          </a:effectRef>
+          <a:fontRef idx="minor">
+            <a:schemeClr val="lt1"/>
+          </a:fontRef>
+        </p:style>
+        <p:txBody>
+          <a:bodyPr rtlCol="0" anchor="ctr"/>
+          <a:lstStyle/>
+          <a:p>
+            <a:pPr algn="ctr"/>
+          </a:p>
+        </p:txBody>
+      </p:sp>
+      <p:sp>
+        <p:nvSpPr>
+          <p:cNvPr id="5" name="TextBox 4"/>
+          <p:cNvSpPr txBox="1"/>
+          <p:nvPr/>
+        </p:nvSpPr>
+        <p:spPr>
+          <a:xfrm>
+            <a:off x="914400" y="1645920"/>
+            <a:ext cx="3063240" cy="4480560"/>
+          </a:xfrm>
+          <a:prstGeom prst="rect">
+            <a:avLst/>
+          </a:prstGeom>
+          <a:noFill/>
+        </p:spPr>
+        <p:txBody>
+          <a:bodyPr wrap="square">
+            <a:spAutoFit/>
+          </a:bodyPr>
+          <a:lstStyle/>
+          <a:p>
+            <a:pPr>
+              <a:defRPr sz="1300" b="1">
+                <a:solidFill>
+                  <a:srgbClr val="4F46E5"/>
+                </a:solidFill>
+              </a:defRPr>
+            </a:pPr>
+            <a:r>
+              <a:t>Yashvi Bhadani (24DIT004)</a:t>
+            </a:r>
+          </a:p>
+          <a:p>
+            <a:pPr>
+              <a:defRPr sz="900" b="1">
+                <a:solidFill>
+                  <a:srgbClr val="64748B"/>
+                </a:solidFill>
+              </a:defRPr>
+            </a:pPr>
+            <a:r>
+              <a:t>DATA ENGINEERING &amp; PIPELINE</a:t>
+            </a:r>
+          </a:p>
+          <a:p>
+            <a:pPr>
+              <a:defRPr sz="1100">
+                <a:solidFill>
+                  <a:srgbClr val="0F172A"/>
+                </a:solidFill>
+              </a:defRPr>
+            </a:pPr>
+            <a:r>
+              <a:t>✔ YouTube Data API v3 integration pipeline</a:t>
+            </a:r>
+          </a:p>
+          <a:p>
+            <a:pPr>
+              <a:defRPr sz="1100">
+                <a:solidFill>
+                  <a:srgbClr val="0F172A"/>
+                </a:solidFill>
+              </a:defRPr>
+            </a:pPr>
+            <a:r>
+              <a:t>✔ Ingested 2,000+ channels and 2,841+ videos</a:t>
+            </a:r>
+          </a:p>
+          <a:p>
+            <a:pPr>
+              <a:defRPr sz="1100">
+                <a:solidFill>
+                  <a:srgbClr val="0F172A"/>
+                </a:solidFill>
+              </a:defRPr>
+            </a:pPr>
+            <a:r>
+              <a:t>✔ MongoDB raw layer architecture &amp; schemas</a:t>
+            </a:r>
+          </a:p>
+          <a:p>
+            <a:pPr>
+              <a:defRPr sz="1100">
+                <a:solidFill>
+                  <a:srgbClr val="0F172A"/>
+                </a:solidFill>
+              </a:defRPr>
+            </a:pPr>
+            <a:r>
+              <a:t>✔ Automated background ingestion tasks</a:t>
+            </a:r>
+          </a:p>
+          <a:p>
+            <a:pPr>
+              <a:defRPr sz="1100">
+                <a:solidFill>
+                  <a:srgbClr val="0F172A"/>
+                </a:solidFill>
+              </a:defRPr>
+            </a:pPr>
+            <a:r>
+              <a:t>→ Feature engineering &amp; data hygiene</a:t>
+            </a:r>
+          </a:p>
+        </p:txBody>
+      </p:sp>
+      <p:sp>
+        <p:nvSpPr>
+          <p:cNvPr id="6" name="Rounded Rectangle 5"/>
+          <p:cNvSpPr/>
+          <p:nvPr/>
+        </p:nvSpPr>
+        <p:spPr>
+          <a:xfrm>
+            <a:off x="4343400" y="1463040"/>
+            <a:ext cx="3429000" cy="4846320"/>
+          </a:xfrm>
+          <a:prstGeom prst="roundRect">
+            <a:avLst/>
+          </a:prstGeom>
+          <a:solidFill>
+            <a:srgbClr val="FFFFFF"/>
+          </a:solidFill>
+          <a:ln w="12700">
+            <a:solidFill>
+              <a:srgbClr val="E2E8F0"/>
+            </a:solidFill>
+          </a:ln>
+        </p:spPr>
+        <p:style>
+          <a:lnRef idx="1">
+            <a:schemeClr val="accent1"/>
+          </a:lnRef>
+          <a:fillRef idx="3">
+            <a:schemeClr val="accent1"/>
+          </a:fillRef>
+          <a:effectRef idx="2">
+            <a:schemeClr val="accent1"/>
+          </a:effectRef>
+          <a:fontRef idx="minor">
+            <a:schemeClr val="lt1"/>
+          </a:fontRef>
+        </p:style>
+        <p:txBody>
+          <a:bodyPr rtlCol="0" anchor="ctr"/>
+          <a:lstStyle/>
+          <a:p>
+            <a:pPr algn="ctr"/>
+          </a:p>
+        </p:txBody>
+      </p:sp>
+      <p:sp>
+        <p:nvSpPr>
+          <p:cNvPr id="7" name="TextBox 6"/>
+          <p:cNvSpPr txBox="1"/>
+          <p:nvPr/>
+        </p:nvSpPr>
+        <p:spPr>
+          <a:xfrm>
+            <a:off x="4526280" y="1645920"/>
+            <a:ext cx="3063240" cy="4480560"/>
+          </a:xfrm>
+          <a:prstGeom prst="rect">
+            <a:avLst/>
+          </a:prstGeom>
+          <a:noFill/>
+        </p:spPr>
+        <p:txBody>
+          <a:bodyPr wrap="square">
+            <a:spAutoFit/>
+          </a:bodyPr>
+          <a:lstStyle/>
+          <a:p>
+            <a:pPr>
+              <a:defRPr sz="1300" b="1">
+                <a:solidFill>
+                  <a:srgbClr val="7C3AED"/>
+                </a:solidFill>
+              </a:defRPr>
+            </a:pPr>
+            <a:r>
+              <a:t>Shivansh (24DIT014)</a:t>
+            </a:r>
+          </a:p>
+          <a:p>
+            <a:pPr>
+              <a:defRPr sz="900" b="1">
+                <a:solidFill>
+                  <a:srgbClr val="64748B"/>
+                </a:solidFill>
+              </a:defRPr>
+            </a:pPr>
+            <a:r>
+              <a:t>UI/UX &amp; NLP ENGINE</a:t>
+            </a:r>
+          </a:p>
+          <a:p>
+            <a:pPr>
+              <a:defRPr sz="1100">
+                <a:solidFill>
+                  <a:srgbClr val="0F172A"/>
+                </a:solidFill>
+              </a:defRPr>
+            </a:pPr>
+            <a:r>
+              <a:t>✔ Complete Figma design system &amp; layouts</a:t>
+            </a:r>
+          </a:p>
+          <a:p>
+            <a:pPr>
+              <a:defRPr sz="1100">
+                <a:solidFill>
+                  <a:srgbClr val="0F172A"/>
+                </a:solidFill>
+              </a:defRPr>
+            </a:pPr>
+            <a:r>
+              <a:t>✔ React 19 + MUI responsive application</a:t>
+            </a:r>
+          </a:p>
+          <a:p>
+            <a:pPr>
+              <a:defRPr sz="1100">
+                <a:solidFill>
+                  <a:srgbClr val="0F172A"/>
+                </a:solidFill>
+              </a:defRPr>
+            </a:pPr>
+            <a:r>
+              <a:t>✔ Sentence-BERT all-MiniLM-L6-v2 integration</a:t>
+            </a:r>
+          </a:p>
+          <a:p>
+            <a:pPr>
+              <a:defRPr sz="1100">
+                <a:solidFill>
+                  <a:srgbClr val="0F172A"/>
+                </a:solidFill>
+              </a:defRPr>
+            </a:pPr>
+            <a:r>
+              <a:t>✔ Cosine similarity tensor calculation</a:t>
+            </a:r>
+          </a:p>
+          <a:p>
+            <a:pPr>
+              <a:defRPr sz="1100">
+                <a:solidFill>
+                  <a:srgbClr val="0F172A"/>
+                </a:solidFill>
+              </a:defRPr>
+            </a:pPr>
+            <a:r>
+              <a:t>→ Graph network modeling &amp; visualization</a:t>
+            </a:r>
+          </a:p>
+        </p:txBody>
+      </p:sp>
+      <p:sp>
+        <p:nvSpPr>
+          <p:cNvPr id="8" name="Rounded Rectangle 7"/>
+          <p:cNvSpPr/>
+          <p:nvPr/>
+        </p:nvSpPr>
+        <p:spPr>
+          <a:xfrm>
+            <a:off x="7955280" y="1463040"/>
+            <a:ext cx="3429000" cy="4846320"/>
+          </a:xfrm>
+          <a:prstGeom prst="roundRect">
+            <a:avLst/>
+          </a:prstGeom>
+          <a:solidFill>
+            <a:srgbClr val="FFFFFF"/>
+          </a:solidFill>
+          <a:ln w="12700">
+            <a:solidFill>
+              <a:srgbClr val="E2E8F0"/>
+            </a:solidFill>
+          </a:ln>
+        </p:spPr>
+        <p:style>
+          <a:lnRef idx="1">
+            <a:schemeClr val="accent1"/>
+          </a:lnRef>
+          <a:fillRef idx="3">
+            <a:schemeClr val="accent1"/>
+          </a:fillRef>
+          <a:effectRef idx="2">
+            <a:schemeClr val="accent1"/>
+          </a:effectRef>
+          <a:fontRef idx="minor">
+            <a:schemeClr val="lt1"/>
+          </a:fontRef>
+        </p:style>
+        <p:txBody>
+          <a:bodyPr rtlCol="0" anchor="ctr"/>
+          <a:lstStyle/>
+          <a:p>
+            <a:pPr algn="ctr"/>
+          </a:p>
+        </p:txBody>
+      </p:sp>
+      <p:sp>
+        <p:nvSpPr>
+          <p:cNvPr id="9" name="TextBox 8"/>
+          <p:cNvSpPr txBox="1"/>
+          <p:nvPr/>
+        </p:nvSpPr>
+        <p:spPr>
+          <a:xfrm>
+            <a:off x="8138160" y="1645920"/>
+            <a:ext cx="3063240" cy="4480560"/>
+          </a:xfrm>
+          <a:prstGeom prst="rect">
+            <a:avLst/>
+          </a:prstGeom>
+          <a:noFill/>
+        </p:spPr>
+        <p:txBody>
+          <a:bodyPr wrap="square">
+            <a:spAutoFit/>
+          </a:bodyPr>
+          <a:lstStyle/>
+          <a:p>
+            <a:pPr>
+              <a:defRPr sz="1300" b="1">
+                <a:solidFill>
+                  <a:srgbClr val="0284C7"/>
+                </a:solidFill>
+              </a:defRPr>
+            </a:pPr>
+            <a:r>
+              <a:t>Astha Makwana (24DIT030)</a:t>
+            </a:r>
+          </a:p>
+          <a:p>
+            <a:pPr>
+              <a:defRPr sz="900" b="1">
+                <a:solidFill>
+                  <a:srgbClr val="64748B"/>
+                </a:solidFill>
+              </a:defRPr>
+            </a:pPr>
+            <a:r>
+              <a:t>SUPABASE DATABASE &amp; ML PREP</a:t>
+            </a:r>
+          </a:p>
+          <a:p>
+            <a:pPr>
+              <a:defRPr sz="1100">
+                <a:solidFill>
+                  <a:srgbClr val="0F172A"/>
+                </a:solidFill>
+              </a:defRPr>
+            </a:pPr>
+            <a:r>
+              <a:t>✔ Supabase PostgreSQL relational schemas</a:t>
+            </a:r>
+          </a:p>
+          <a:p>
+            <a:pPr>
+              <a:defRPr sz="1100">
+                <a:solidFill>
+                  <a:srgbClr val="0F172A"/>
+                </a:solidFill>
+              </a:defRPr>
+            </a:pPr>
+            <a:r>
+              <a:t>✔ Client &amp; Server Supabase Auth (JWT Bearer)</a:t>
+            </a:r>
+          </a:p>
+          <a:p>
+            <a:pPr>
+              <a:defRPr sz="1100">
+                <a:solidFill>
+                  <a:srgbClr val="0F172A"/>
+                </a:solidFill>
+              </a:defRPr>
+            </a:pPr>
+            <a:r>
+              <a:t>✔ Row-Level Security (RLS) &amp; Public Views</a:t>
+            </a:r>
+          </a:p>
+          <a:p>
+            <a:pPr>
+              <a:defRPr sz="1100">
+                <a:solidFill>
+                  <a:srgbClr val="0F172A"/>
+                </a:solidFill>
+              </a:defRPr>
+            </a:pPr>
+            <a:r>
+              <a:t>✔ registered_channels table &amp; Zero N+1 query</a:t>
+            </a:r>
+          </a:p>
+          <a:p>
+            <a:pPr>
+              <a:defRPr sz="1100">
+                <a:solidFill>
+                  <a:srgbClr val="0F172A"/>
+                </a:solidFill>
+              </a:defRPr>
+            </a:pPr>
+            <a:r>
+              <a:t>→ Model tuning &amp; offline ranking evaluation</a:t>
+            </a:r>
+          </a:p>
+        </p:txBody>
+      </p:sp>
+    </p:spTree>
+  </p:cSld>
+  <p:clrMapOvr>
+    <a:masterClrMapping/>
+  </p:clrMapOvr>
+</p:sld>
+</file>
+
+<file path=ppt/slides/slide19.xml><?xml version="1.0" encoding="utf-8"?>
+<p:sld xmlns:a="http://schemas.openxmlformats.org/drawingml/2006/main" xmlns:p="http://schemas.openxmlformats.org/presentationml/2006/main" xmlns:r="http://schemas.openxmlformats.org/officeDocument/2006/relationships">
+  <p:cSld>
+    <p:bg>
+      <p:bgPr>
+        <a:solidFill>
+          <a:srgbClr val="F8FAFC"/>
+        </a:solidFill>
+        <a:effectLst/>
+      </p:bgPr>
+    </p:bg>
+    <p:spTree>
+      <p:nvGrpSpPr>
+        <p:cNvPr id="1" name=""/>
+        <p:cNvGrpSpPr/>
+        <p:nvPr/>
+      </p:nvGrpSpPr>
+      <p:grpSpPr/>
+      <p:sp>
+        <p:nvSpPr>
+          <p:cNvPr id="2" name="TextBox 1"/>
+          <p:cNvSpPr txBox="1"/>
+          <p:nvPr/>
+        </p:nvSpPr>
+        <p:spPr>
+          <a:xfrm>
+            <a:off x="731520" y="365760"/>
+            <a:ext cx="10698480" cy="365760"/>
+          </a:xfrm>
+          <a:prstGeom prst="rect">
+            <a:avLst/>
+          </a:prstGeom>
+          <a:noFill/>
+        </p:spPr>
+        <p:txBody>
+          <a:bodyPr wrap="square">
+            <a:spAutoFit/>
+          </a:bodyPr>
+          <a:lstStyle/>
+          <a:p>
+            <a:pPr>
+              <a:defRPr sz="1000" b="1">
+                <a:solidFill>
+                  <a:srgbClr val="4F46E5"/>
+                </a:solidFill>
+              </a:defRPr>
+            </a:pPr>
+            <a:r>
+              <a:t>INFLUENCEAI — AI-POWERED RECOMMENDATION SYSTEM</a:t>
+            </a:r>
+          </a:p>
+        </p:txBody>
+      </p:sp>
+      <p:sp>
+        <p:nvSpPr>
+          <p:cNvPr id="3" name="TextBox 2"/>
+          <p:cNvSpPr txBox="1"/>
+          <p:nvPr/>
+        </p:nvSpPr>
+        <p:spPr>
+          <a:xfrm>
+            <a:off x="731520" y="640080"/>
+            <a:ext cx="10698480" cy="731520"/>
+          </a:xfrm>
+          <a:prstGeom prst="rect">
+            <a:avLst/>
+          </a:prstGeom>
+          <a:noFill/>
+        </p:spPr>
+        <p:txBody>
+          <a:bodyPr wrap="square">
+            <a:spAutoFit/>
+          </a:bodyPr>
+          <a:lstStyle/>
+          <a:p>
+            <a:pPr>
+              <a:defRPr sz="2200" b="1">
+                <a:solidFill>
+                  <a:srgbClr val="0F172A"/>
+                </a:solidFill>
+              </a:defRPr>
+            </a:pPr>
+            <a:r>
+              <a:t>Current Implementation Status &amp; Future Roadmap</a:t>
+            </a:r>
+          </a:p>
+        </p:txBody>
+      </p:sp>
+      <p:sp>
+        <p:nvSpPr>
+          <p:cNvPr id="4" name="Rounded Rectangle 3"/>
+          <p:cNvSpPr/>
+          <p:nvPr/>
+        </p:nvSpPr>
+        <p:spPr>
+          <a:xfrm>
+            <a:off x="731520" y="1463040"/>
+            <a:ext cx="5120640" cy="4846320"/>
+          </a:xfrm>
+          <a:prstGeom prst="roundRect">
+            <a:avLst/>
+          </a:prstGeom>
+          <a:solidFill>
+            <a:srgbClr val="FFFFFF"/>
+          </a:solidFill>
+          <a:ln w="12700">
+            <a:solidFill>
+              <a:srgbClr val="E2E8F0"/>
+            </a:solidFill>
+          </a:ln>
+        </p:spPr>
+        <p:style>
+          <a:lnRef idx="1">
+            <a:schemeClr val="accent1"/>
+          </a:lnRef>
+          <a:fillRef idx="3">
+            <a:schemeClr val="accent1"/>
+          </a:fillRef>
+          <a:effectRef idx="2">
+            <a:schemeClr val="accent1"/>
+          </a:effectRef>
+          <a:fontRef idx="minor">
+            <a:schemeClr val="lt1"/>
+          </a:fontRef>
+        </p:style>
+        <p:txBody>
+          <a:bodyPr rtlCol="0" anchor="ctr"/>
+          <a:lstStyle/>
+          <a:p>
+            <a:pPr algn="ctr"/>
+          </a:p>
+        </p:txBody>
+      </p:sp>
+      <p:sp>
+        <p:nvSpPr>
+          <p:cNvPr id="5" name="TextBox 4"/>
+          <p:cNvSpPr txBox="1"/>
+          <p:nvPr/>
+        </p:nvSpPr>
+        <p:spPr>
+          <a:xfrm>
+            <a:off x="914400" y="1645920"/>
+            <a:ext cx="4754880" cy="4480560"/>
+          </a:xfrm>
+          <a:prstGeom prst="rect">
+            <a:avLst/>
+          </a:prstGeom>
+          <a:noFill/>
+        </p:spPr>
+        <p:txBody>
+          <a:bodyPr wrap="square">
+            <a:spAutoFit/>
+          </a:bodyPr>
+          <a:lstStyle/>
+          <a:p>
+            <a:pPr>
+              <a:defRPr sz="1500" b="1">
+                <a:solidFill>
+                  <a:srgbClr val="10B981"/>
+                </a:solidFill>
+              </a:defRPr>
+            </a:pPr>
+            <a:r>
+              <a:t>Completed &amp; Live in Current Build</a:t>
+            </a:r>
+          </a:p>
+          <a:p>
+            <a:pPr>
+              <a:defRPr sz="1100" b="1">
+                <a:solidFill>
+                  <a:srgbClr val="0F172A"/>
+                </a:solidFill>
+              </a:defRPr>
+            </a:pPr>
+            <a:r>
+              <a:t>✔ Full-Stack Integration:</a:t>
+            </a:r>
+          </a:p>
+          <a:p>
+            <a:pPr>
+              <a:defRPr sz="1000">
+                <a:solidFill>
+                  <a:srgbClr val="64748B"/>
+                </a:solidFill>
+              </a:defRPr>
+            </a:pPr>
+            <a:r>
+              <a:t>   React frontend, Express gateway, and FastAPI AI engine running simultaneously with zero CORS errors.</a:t>
+            </a:r>
+          </a:p>
+          <a:p>
+            <a:pPr>
+              <a:defRPr sz="1100" b="1">
+                <a:solidFill>
+                  <a:srgbClr val="0F172A"/>
+                </a:solidFill>
+              </a:defRPr>
+            </a:pPr>
+            <a:r>
+              <a:t>✔ Supabase Auth &amp; RLS:</a:t>
+            </a:r>
+          </a:p>
+          <a:p>
+            <a:pPr>
+              <a:defRPr sz="1000">
+                <a:solidFill>
+                  <a:srgbClr val="64748B"/>
+                </a:solidFill>
+              </a:defRPr>
+            </a:pPr>
+            <a:r>
+              <a:t>   Dual-role signup, session persistence with onAuthStateChange, and protected FastAPI endpoints.</a:t>
+            </a:r>
+          </a:p>
+          <a:p>
+            <a:pPr>
+              <a:defRPr sz="1100" b="1">
+                <a:solidFill>
+                  <a:srgbClr val="0F172A"/>
+                </a:solidFill>
+              </a:defRPr>
+            </a:pPr>
+            <a:r>
+              <a:t>✔ Live SBERT Recommender:</a:t>
+            </a:r>
+          </a:p>
+          <a:p>
+            <a:pPr>
+              <a:defRPr sz="1000">
+                <a:solidFill>
+                  <a:srgbClr val="64748B"/>
+                </a:solidFill>
+              </a:defRPr>
+            </a:pPr>
+            <a:r>
+              <a:t>   Campaign briefs generate instant ranked recommendations with real similarity and engagement scores.</a:t>
+            </a:r>
+          </a:p>
+          <a:p>
+            <a:pPr>
+              <a:defRPr sz="1100" b="1">
+                <a:solidFill>
+                  <a:srgbClr val="0F172A"/>
+                </a:solidFill>
+              </a:defRPr>
+            </a:pPr>
+            <a:r>
+              <a:t>✔ Creator Registration Page:</a:t>
+            </a:r>
+          </a:p>
+          <a:p>
+            <a:pPr>
+              <a:defRPr sz="1000">
+                <a:solidFill>
+                  <a:srgbClr val="64748B"/>
+                </a:solidFill>
+              </a:defRPr>
+            </a:pPr>
+            <a:r>
+              <a:t>   Creators register YouTube IDs/handles; background ingestion syncs channel into ml_data.channels in real time.</a:t>
+            </a:r>
+          </a:p>
+          <a:p>
+            <a:pPr>
+              <a:defRPr sz="1100" b="1">
+                <a:solidFill>
+                  <a:srgbClr val="0F172A"/>
+                </a:solidFill>
+              </a:defRPr>
+            </a:pPr>
+            <a:r>
+              <a:t>✔ Zero N+1 Public Email Sync:</a:t>
+            </a:r>
+          </a:p>
+          <a:p>
+            <a:pPr>
+              <a:defRPr sz="1000">
+                <a:solidFill>
+                  <a:srgbClr val="64748B"/>
+                </a:solidFill>
+              </a:defRPr>
+            </a:pPr>
+            <a:r>
+              <a:t>   Single batched query maps contact emails to recommendations.</a:t>
+            </a:r>
+          </a:p>
+        </p:txBody>
+      </p:sp>
+      <p:sp>
+        <p:nvSpPr>
+          <p:cNvPr id="6" name="Rounded Rectangle 5"/>
+          <p:cNvSpPr/>
+          <p:nvPr/>
+        </p:nvSpPr>
+        <p:spPr>
+          <a:xfrm>
+            <a:off x="6217920" y="1463040"/>
+            <a:ext cx="5212080" cy="4846320"/>
+          </a:xfrm>
+          <a:prstGeom prst="roundRect">
+            <a:avLst/>
+          </a:prstGeom>
+          <a:solidFill>
+            <a:srgbClr val="FFFFFF"/>
+          </a:solidFill>
+          <a:ln w="12700">
+            <a:solidFill>
+              <a:srgbClr val="E2E8F0"/>
+            </a:solidFill>
+          </a:ln>
+        </p:spPr>
+        <p:style>
+          <a:lnRef idx="1">
+            <a:schemeClr val="accent1"/>
+          </a:lnRef>
+          <a:fillRef idx="3">
+            <a:schemeClr val="accent1"/>
+          </a:fillRef>
+          <a:effectRef idx="2">
+            <a:schemeClr val="accent1"/>
+          </a:effectRef>
+          <a:fontRef idx="minor">
+            <a:schemeClr val="lt1"/>
+          </a:fontRef>
+        </p:style>
+        <p:txBody>
+          <a:bodyPr rtlCol="0" anchor="ctr"/>
+          <a:lstStyle/>
+          <a:p>
+            <a:pPr algn="ctr"/>
+          </a:p>
+        </p:txBody>
+      </p:sp>
+      <p:sp>
+        <p:nvSpPr>
+          <p:cNvPr id="7" name="TextBox 6"/>
+          <p:cNvSpPr txBox="1"/>
+          <p:nvPr/>
+        </p:nvSpPr>
+        <p:spPr>
+          <a:xfrm>
+            <a:off x="6400800" y="1645920"/>
+            <a:ext cx="4846320" cy="4480560"/>
+          </a:xfrm>
+          <a:prstGeom prst="rect">
+            <a:avLst/>
+          </a:prstGeom>
+          <a:noFill/>
+        </p:spPr>
+        <p:txBody>
+          <a:bodyPr wrap="square">
+            <a:spAutoFit/>
+          </a:bodyPr>
+          <a:lstStyle/>
+          <a:p>
+            <a:pPr>
+              <a:defRPr sz="1500" b="1">
+                <a:solidFill>
+                  <a:srgbClr val="4F46E5"/>
+                </a:solidFill>
+              </a:defRPr>
+            </a:pPr>
+            <a:r>
+              <a:t>Future Technical Roadmap (Semester 6)</a:t>
+            </a:r>
+          </a:p>
+          <a:p>
+            <a:pPr>
+              <a:defRPr sz="1100" b="1">
+                <a:solidFill>
+                  <a:srgbClr val="0F172A"/>
+                </a:solidFill>
+              </a:defRPr>
+            </a:pPr>
+            <a:r>
+              <a:t>→ Graph-Based Authority Analysis:</a:t>
+            </a:r>
+          </a:p>
+          <a:p>
+            <a:pPr>
+              <a:defRPr sz="1000">
+                <a:solidFill>
+                  <a:srgbClr val="64748B"/>
+                </a:solidFill>
+              </a:defRPr>
+            </a:pPr>
+            <a:r>
+              <a:t>   Construct creator co-mention networks and calculate PageRank and Betweenness Centrality for community hubs.</a:t>
+            </a:r>
+          </a:p>
+          <a:p>
+            <a:pPr>
+              <a:defRPr sz="1100" b="1">
+                <a:solidFill>
+                  <a:srgbClr val="0F172A"/>
+                </a:solidFill>
+              </a:defRPr>
+            </a:pPr>
+            <a:r>
+              <a:t>→ Google OAuth Channel Ownership:</a:t>
+            </a:r>
+          </a:p>
+          <a:p>
+            <a:pPr>
+              <a:defRPr sz="1000">
+                <a:solidFill>
+                  <a:srgbClr val="64748B"/>
+                </a:solidFill>
+              </a:defRPr>
+            </a:pPr>
+            <a:r>
+              <a:t>   Implement youtube.readonly OAuth scope (channels.list mine=true) to cryptographically verify channel ownership.</a:t>
+            </a:r>
+          </a:p>
+          <a:p>
+            <a:pPr>
+              <a:defRPr sz="1100" b="1">
+                <a:solidFill>
+                  <a:srgbClr val="0F172A"/>
+                </a:solidFill>
+              </a:defRPr>
+            </a:pPr>
+            <a:r>
+              <a:t>→ Cross-Platform Expansion:</a:t>
+            </a:r>
+          </a:p>
+          <a:p>
+            <a:pPr>
+              <a:defRPr sz="1000">
+                <a:solidFill>
+                  <a:srgbClr val="64748B"/>
+                </a:solidFill>
+              </a:defRPr>
+            </a:pPr>
+            <a:r>
+              <a:t>   Ingest Instagram Reels and TikTok creator metrics alongside YouTube Data API.</a:t>
+            </a:r>
+          </a:p>
+          <a:p>
+            <a:pPr>
+              <a:defRPr sz="1100" b="1">
+                <a:solidFill>
+                  <a:srgbClr val="0F172A"/>
+                </a:solidFill>
+              </a:defRPr>
+            </a:pPr>
+            <a:r>
+              <a:t>→ Offline Model Evaluation:</a:t>
+            </a:r>
+          </a:p>
+          <a:p>
+            <a:pPr>
+              <a:defRPr sz="1000">
+                <a:solidFill>
+                  <a:srgbClr val="64748B"/>
+                </a:solidFill>
+              </a:defRPr>
+            </a:pPr>
+            <a:r>
+              <a:t>   Benchmark ranking quality with NDCG@10 (Normalized Discounted Cumulative Gain) and Mean Reciprocal Rank (MRR).</a:t>
             </a:r>
           </a:p>
         </p:txBody>
@@ -9745,6 +9740,113 @@
             </a:pPr>
             <a:r>
               <a:t>   Every recommendation details its semantic match %, engagement score %, tier suitability, and direct contact email.</a:t>
+            </a:r>
+          </a:p>
+        </p:txBody>
+      </p:sp>
+    </p:spTree>
+  </p:cSld>
+  <p:clrMapOvr>
+    <a:masterClrMapping/>
+  </p:clrMapOvr>
+</p:sld>
+</file>
+
+<file path=ppt/slides/slide20.xml><?xml version="1.0" encoding="utf-8"?>
+<p:sld xmlns:a="http://schemas.openxmlformats.org/drawingml/2006/main" xmlns:p="http://schemas.openxmlformats.org/presentationml/2006/main" xmlns:r="http://schemas.openxmlformats.org/officeDocument/2006/relationships">
+  <p:cSld>
+    <p:bg>
+      <p:bgPr>
+        <a:solidFill>
+          <a:srgbClr val="0F172A"/>
+        </a:solidFill>
+        <a:effectLst/>
+      </p:bgPr>
+    </p:bg>
+    <p:spTree>
+      <p:nvGrpSpPr>
+        <p:cNvPr id="1" name=""/>
+        <p:cNvGrpSpPr/>
+        <p:nvPr/>
+      </p:nvGrpSpPr>
+      <p:grpSpPr/>
+      <p:sp>
+        <p:nvSpPr>
+          <p:cNvPr id="2" name="TextBox 1"/>
+          <p:cNvSpPr txBox="1"/>
+          <p:nvPr/>
+        </p:nvSpPr>
+        <p:spPr>
+          <a:xfrm>
+            <a:off x="1371600" y="1645920"/>
+            <a:ext cx="9418320" cy="3657600"/>
+          </a:xfrm>
+          <a:prstGeom prst="rect">
+            <a:avLst/>
+          </a:prstGeom>
+          <a:noFill/>
+        </p:spPr>
+        <p:txBody>
+          <a:bodyPr wrap="square">
+            <a:spAutoFit/>
+          </a:bodyPr>
+          <a:lstStyle/>
+          <a:p>
+            <a:pPr algn="ctr">
+              <a:defRPr sz="4000" b="1">
+                <a:solidFill>
+                  <a:srgbClr val="FFFFFF"/>
+                </a:solidFill>
+              </a:defRPr>
+            </a:pPr>
+            <a:r>
+              <a:t>InfluenceAI</a:t>
+            </a:r>
+          </a:p>
+          <a:p>
+            <a:pPr algn="ctr">
+              <a:defRPr sz="1800">
+                <a:solidFill>
+                  <a:srgbClr val="4F46E5"/>
+                </a:solidFill>
+              </a:defRPr>
+            </a:pPr>
+            <a:r>
+              <a:t>From Unfiltered Search to Intelligent, Explainable Recommendation</a:t>
+            </a:r>
+          </a:p>
+          <a:p>
+            <a:br/>
+            <a:pPr algn="ctr">
+              <a:defRPr sz="1500">
+                <a:solidFill>
+                  <a:srgbClr val="CBD5E1"/>
+                </a:solidFill>
+              </a:defRPr>
+            </a:pPr>
+            <a:r>
+              <a:t>Thank you for your valuable guidance and attention.</a:t>
+            </a:r>
+            <a:br/>
+            <a:r>
+              <a:t>We welcome your questions and feedback.</a:t>
+            </a:r>
+          </a:p>
+          <a:p>
+            <a:br/>
+            <a:pPr algn="ctr">
+              <a:defRPr sz="1200">
+                <a:solidFill>
+                  <a:srgbClr val="94A3B8"/>
+                </a:solidFill>
+              </a:defRPr>
+            </a:pPr>
+            <a:r>
+              <a:t>24DIT004 (Yashvi)  ·  24DIT014 (Shivansh)  ·  24DIT030 (Astha)</a:t>
+            </a:r>
+            <a:br/>
+            <a:r>
+              <a:t>CHARUSAT  ·  DEPSTAR  ·  IT Dept</a:t>
             </a:r>
           </a:p>
         </p:txBody>

</xml_diff>